<commit_message>
Remove no-model results from slide deck
</commit_message>
<xml_diff>
--- a/docs/stream_project_slide_deck.pptx
+++ b/docs/stream_project_slide_deck.pptx
@@ -4222,7 +4222,7 @@
             <a:avLst/>
           </a:prstGeom>
           <a:solidFill>
-            <a:srgbClr val="E8ECF0"/>
+            <a:srgbClr val="E1EBF7"/>
           </a:solidFill>
           <a:ln w="13970">
             <a:solidFill>
@@ -4291,7 +4291,7 @@
                 </a:solidFill>
                 <a:latin typeface="Aptos"/>
               </a:rPr>
-              <a:t>0.110</a:t>
+              <a:t>0.157</a:t>
             </a:r>
           </a:p>
         </p:txBody>
@@ -4326,7 +4326,7 @@
                 </a:solidFill>
                 <a:latin typeface="Aptos"/>
               </a:rPr>
-              <a:t>relative no model</a:t>
+              <a:t>relative zebrafish only</a:t>
             </a:r>
           </a:p>
         </p:txBody>
@@ -4485,7 +4485,7 @@
                 </a:solidFill>
                 <a:latin typeface="Aptos"/>
               </a:rPr>
-              <a:t>Lower displacement MAE is better. The persistence baseline remains strong.</a:t>
+              <a:t>Lower displacement MAE is better. Bars compare learned transfer and target-only regimes.</a:t>
             </a:r>
           </a:p>
         </p:txBody>
@@ -4546,7 +4546,7 @@
                 </a:solidFill>
                 <a:latin typeface="Aptos"/>
               </a:rPr>
-              <a:t>Cross-species generalization is visible but not yet enough to beat persistence</a:t>
+              <a:t>Cross-species generalization depends on the time coordinate and training regime</a:t>
             </a:r>
           </a:p>
         </p:txBody>
@@ -4575,7 +4575,7 @@
                 <a:gridCol w="1714500"/>
                 <a:gridCol w="1714500"/>
               </a:tblGrid>
-              <a:tr h="421640">
+              <a:tr h="542108">
                 <a:tc>
                   <a:txBody>
                     <a:bodyPr/>
@@ -4669,7 +4669,7 @@
                   </a:tcPr>
                 </a:tc>
               </a:tr>
-              <a:tr h="421640">
+              <a:tr h="542108">
                 <a:tc>
                   <a:txBody>
                     <a:bodyPr/>
@@ -4706,7 +4706,7 @@
                           </a:solidFill>
                           <a:latin typeface="Aptos"/>
                         </a:rPr>
-                        <a:t>No model</a:t>
+                        <a:t>Mouse zero-shot</a:t>
                       </a:r>
                     </a:p>
                   </a:txBody>
@@ -4729,7 +4729,7 @@
                           </a:solidFill>
                           <a:latin typeface="Aptos"/>
                         </a:rPr>
-                        <a:t>0.110</a:t>
+                        <a:t>0.184</a:t>
                       </a:r>
                     </a:p>
                   </a:txBody>
@@ -4752,7 +4752,7 @@
                           </a:solidFill>
                           <a:latin typeface="Aptos"/>
                         </a:rPr>
-                        <a:t>3.325</a:t>
+                        <a:t>3.348</a:t>
                       </a:r>
                     </a:p>
                   </a:txBody>
@@ -4763,7 +4763,7 @@
                   </a:tcPr>
                 </a:tc>
               </a:tr>
-              <a:tr h="421640">
+              <a:tr h="542108">
                 <a:tc>
                   <a:txBody>
                     <a:bodyPr/>
@@ -4800,7 +4800,7 @@
                           </a:solidFill>
                           <a:latin typeface="Aptos"/>
                         </a:rPr>
-                        <a:t>Mouse zero-shot</a:t>
+                        <a:t>Mouse -&gt; zebrafish</a:t>
                       </a:r>
                     </a:p>
                   </a:txBody>
@@ -4823,7 +4823,7 @@
                           </a:solidFill>
                           <a:latin typeface="Aptos"/>
                         </a:rPr>
-                        <a:t>0.184</a:t>
+                        <a:t>0.131</a:t>
                       </a:r>
                     </a:p>
                   </a:txBody>
@@ -4846,7 +4846,7 @@
                           </a:solidFill>
                           <a:latin typeface="Aptos"/>
                         </a:rPr>
-                        <a:t>3.348</a:t>
+                        <a:t>3.325</a:t>
                       </a:r>
                     </a:p>
                   </a:txBody>
@@ -4857,7 +4857,7 @@
                   </a:tcPr>
                 </a:tc>
               </a:tr>
-              <a:tr h="421640">
+              <a:tr h="542108">
                 <a:tc>
                   <a:txBody>
                     <a:bodyPr/>
@@ -4894,7 +4894,7 @@
                           </a:solidFill>
                           <a:latin typeface="Aptos"/>
                         </a:rPr>
-                        <a:t>Mouse -&gt; zebrafish</a:t>
+                        <a:t>Zebrafish only</a:t>
                       </a:r>
                     </a:p>
                   </a:txBody>
@@ -4917,7 +4917,7 @@
                           </a:solidFill>
                           <a:latin typeface="Aptos"/>
                         </a:rPr>
-                        <a:t>0.131</a:t>
+                        <a:t>0.157</a:t>
                       </a:r>
                     </a:p>
                   </a:txBody>
@@ -4940,7 +4940,7 @@
                           </a:solidFill>
                           <a:latin typeface="Aptos"/>
                         </a:rPr>
-                        <a:t>3.325</a:t>
+                        <a:t>3.331</a:t>
                       </a:r>
                     </a:p>
                   </a:txBody>
@@ -4951,195 +4951,7 @@
                   </a:tcPr>
                 </a:tc>
               </a:tr>
-              <a:tr h="421640">
-                <a:tc>
-                  <a:txBody>
-                    <a:bodyPr/>
-                    <a:lstStyle/>
-                    <a:p>
-                      <a:pPr algn="ctr"/>
-                      <a:r>
-                        <a:rPr sz="1000">
-                          <a:solidFill>
-                            <a:srgbClr val="20252A"/>
-                          </a:solidFill>
-                          <a:latin typeface="Aptos"/>
-                        </a:rPr>
-                        <a:t>Relative time</a:t>
-                      </a:r>
-                    </a:p>
-                  </a:txBody>
-                  <a:tcPr>
-                    <a:solidFill>
-                      <a:srgbClr val="F1F4F7"/>
-                    </a:solidFill>
-                  </a:tcPr>
-                </a:tc>
-                <a:tc>
-                  <a:txBody>
-                    <a:bodyPr/>
-                    <a:lstStyle/>
-                    <a:p>
-                      <a:pPr algn="ctr"/>
-                      <a:r>
-                        <a:rPr sz="1000">
-                          <a:solidFill>
-                            <a:srgbClr val="20252A"/>
-                          </a:solidFill>
-                          <a:latin typeface="Aptos"/>
-                        </a:rPr>
-                        <a:t>Zebrafish only</a:t>
-                      </a:r>
-                    </a:p>
-                  </a:txBody>
-                  <a:tcPr>
-                    <a:solidFill>
-                      <a:srgbClr val="F1F4F7"/>
-                    </a:solidFill>
-                  </a:tcPr>
-                </a:tc>
-                <a:tc>
-                  <a:txBody>
-                    <a:bodyPr/>
-                    <a:lstStyle/>
-                    <a:p>
-                      <a:pPr algn="ctr"/>
-                      <a:r>
-                        <a:rPr sz="1000">
-                          <a:solidFill>
-                            <a:srgbClr val="20252A"/>
-                          </a:solidFill>
-                          <a:latin typeface="Aptos"/>
-                        </a:rPr>
-                        <a:t>0.157</a:t>
-                      </a:r>
-                    </a:p>
-                  </a:txBody>
-                  <a:tcPr>
-                    <a:solidFill>
-                      <a:srgbClr val="F1F4F7"/>
-                    </a:solidFill>
-                  </a:tcPr>
-                </a:tc>
-                <a:tc>
-                  <a:txBody>
-                    <a:bodyPr/>
-                    <a:lstStyle/>
-                    <a:p>
-                      <a:pPr algn="ctr"/>
-                      <a:r>
-                        <a:rPr sz="1000">
-                          <a:solidFill>
-                            <a:srgbClr val="20252A"/>
-                          </a:solidFill>
-                          <a:latin typeface="Aptos"/>
-                        </a:rPr>
-                        <a:t>3.331</a:t>
-                      </a:r>
-                    </a:p>
-                  </a:txBody>
-                  <a:tcPr>
-                    <a:solidFill>
-                      <a:srgbClr val="F1F4F7"/>
-                    </a:solidFill>
-                  </a:tcPr>
-                </a:tc>
-              </a:tr>
-              <a:tr h="421640">
-                <a:tc>
-                  <a:txBody>
-                    <a:bodyPr/>
-                    <a:lstStyle/>
-                    <a:p>
-                      <a:pPr algn="ctr"/>
-                      <a:r>
-                        <a:rPr sz="1000">
-                          <a:solidFill>
-                            <a:srgbClr val="20252A"/>
-                          </a:solidFill>
-                          <a:latin typeface="Aptos"/>
-                        </a:rPr>
-                        <a:t>Physical days</a:t>
-                      </a:r>
-                    </a:p>
-                  </a:txBody>
-                  <a:tcPr>
-                    <a:solidFill>
-                      <a:srgbClr val="FFFFFF"/>
-                    </a:solidFill>
-                  </a:tcPr>
-                </a:tc>
-                <a:tc>
-                  <a:txBody>
-                    <a:bodyPr/>
-                    <a:lstStyle/>
-                    <a:p>
-                      <a:pPr algn="ctr"/>
-                      <a:r>
-                        <a:rPr sz="1000">
-                          <a:solidFill>
-                            <a:srgbClr val="20252A"/>
-                          </a:solidFill>
-                          <a:latin typeface="Aptos"/>
-                        </a:rPr>
-                        <a:t>No model</a:t>
-                      </a:r>
-                    </a:p>
-                  </a:txBody>
-                  <a:tcPr>
-                    <a:solidFill>
-                      <a:srgbClr val="FFFFFF"/>
-                    </a:solidFill>
-                  </a:tcPr>
-                </a:tc>
-                <a:tc>
-                  <a:txBody>
-                    <a:bodyPr/>
-                    <a:lstStyle/>
-                    <a:p>
-                      <a:pPr algn="ctr"/>
-                      <a:r>
-                        <a:rPr sz="1000">
-                          <a:solidFill>
-                            <a:srgbClr val="20252A"/>
-                          </a:solidFill>
-                          <a:latin typeface="Aptos"/>
-                        </a:rPr>
-                        <a:t>0.110</a:t>
-                      </a:r>
-                    </a:p>
-                  </a:txBody>
-                  <a:tcPr>
-                    <a:solidFill>
-                      <a:srgbClr val="FFFFFF"/>
-                    </a:solidFill>
-                  </a:tcPr>
-                </a:tc>
-                <a:tc>
-                  <a:txBody>
-                    <a:bodyPr/>
-                    <a:lstStyle/>
-                    <a:p>
-                      <a:pPr algn="ctr"/>
-                      <a:r>
-                        <a:rPr sz="1000">
-                          <a:solidFill>
-                            <a:srgbClr val="20252A"/>
-                          </a:solidFill>
-                          <a:latin typeface="Aptos"/>
-                        </a:rPr>
-                        <a:t>3.325</a:t>
-                      </a:r>
-                    </a:p>
-                  </a:txBody>
-                  <a:tcPr>
-                    <a:solidFill>
-                      <a:srgbClr val="FFFFFF"/>
-                    </a:solidFill>
-                  </a:tcPr>
-                </a:tc>
-              </a:tr>
-              <a:tr h="421640">
+              <a:tr h="542108">
                 <a:tc>
                   <a:txBody>
                     <a:bodyPr/>
@@ -5233,7 +5045,7 @@
                   </a:tcPr>
                 </a:tc>
               </a:tr>
-              <a:tr h="421640">
+              <a:tr h="542108">
                 <a:tc>
                   <a:txBody>
                     <a:bodyPr/>
@@ -5327,7 +5139,7 @@
                   </a:tcPr>
                 </a:tc>
               </a:tr>
-              <a:tr h="421640">
+              <a:tr h="542112">
                 <a:tc>
                   <a:txBody>
                     <a:bodyPr/>
@@ -5548,11 +5360,11 @@
             <a:avLst/>
           </a:prstGeom>
           <a:solidFill>
-            <a:srgbClr val="F9E0DC"/>
+            <a:srgbClr val="E1EBF7"/>
           </a:solidFill>
           <a:ln w="13970">
             <a:solidFill>
-              <a:srgbClr val="BE4B49"/>
+              <a:srgbClr val="3165A3"/>
             </a:solidFill>
           </a:ln>
         </p:spPr>
@@ -5582,7 +5394,7 @@
                 </a:solidFill>
                 <a:latin typeface="Aptos"/>
               </a:rPr>
-              <a:t>No-model displacement is still lower, so endpoint movement is small relative to expression scale</a:t>
+              <a:t>Zebrafish-only training is weaker than transfer-started models in both time coordinates</a:t>
             </a:r>
           </a:p>
         </p:txBody>
@@ -5992,7 +5804,7 @@
                           </a:solidFill>
                           <a:latin typeface="Aptos"/>
                         </a:rPr>
-                        <a:t>Promising but incomplete</a:t>
+                        <a:t>Transfer signal appears</a:t>
                       </a:r>
                     </a:p>
                   </a:txBody>
@@ -6015,7 +5827,7 @@
                           </a:solidFill>
                           <a:latin typeface="Aptos"/>
                         </a:rPr>
-                        <a:t>Fine-tuning helps; persistence is hard to beat</a:t>
+                        <a:t>Fine-tuning helps in relative time</a:t>
                       </a:r>
                     </a:p>
                   </a:txBody>
@@ -11895,60 +11707,6 @@
         </p:nvSpPr>
         <p:spPr>
           <a:xfrm>
-            <a:off x="5486400" y="3977639"/>
-            <a:ext cx="1554480" cy="640080"/>
-          </a:xfrm>
-          <a:prstGeom prst="roundRect">
-            <a:avLst/>
-          </a:prstGeom>
-          <a:solidFill>
-            <a:srgbClr val="E8ECF0"/>
-          </a:solidFill>
-          <a:ln w="13970">
-            <a:solidFill>
-              <a:srgbClr val="5C6773"/>
-            </a:solidFill>
-          </a:ln>
-        </p:spPr>
-        <p:style>
-          <a:lnRef idx="1">
-            <a:schemeClr val="accent1"/>
-          </a:lnRef>
-          <a:fillRef idx="3">
-            <a:schemeClr val="accent1"/>
-          </a:fillRef>
-          <a:effectRef idx="2">
-            <a:schemeClr val="accent1"/>
-          </a:effectRef>
-          <a:fontRef idx="minor">
-            <a:schemeClr val="lt1"/>
-          </a:fontRef>
-        </p:style>
-        <p:txBody>
-          <a:bodyPr rtlCol="0" anchor="ctr" lIns="73152" rIns="73152" tIns="54864" bIns="54864"/>
-          <a:lstStyle/>
-          <a:p>
-            <a:pPr algn="ctr"/>
-            <a:r>
-              <a:rPr sz="1300" b="1">
-                <a:solidFill>
-                  <a:srgbClr val="20252A"/>
-                </a:solidFill>
-                <a:latin typeface="Aptos"/>
-              </a:rPr>
-              <a:t>no model</a:t>
-            </a:r>
-          </a:p>
-        </p:txBody>
-      </p:sp>
-      <p:sp>
-        <p:nvSpPr>
-          <p:cNvPr id="11" name="Rounded Rectangle 10"/>
-          <p:cNvSpPr/>
-          <p:nvPr/>
-        </p:nvSpPr>
-        <p:spPr>
-          <a:xfrm>
             <a:off x="7635240" y="2240280"/>
             <a:ext cx="3017520" cy="960120"/>
           </a:xfrm>
@@ -11998,14 +11756,49 @@
       </p:sp>
       <p:cxnSp>
         <p:nvCxnSpPr>
+          <p:cNvPr id="11" name="Connector 10"/>
+          <p:cNvCxnSpPr/>
+          <p:nvPr/>
+        </p:nvCxnSpPr>
+        <p:spPr>
+          <a:xfrm>
+            <a:off x="2788920" y="1755648"/>
+            <a:ext cx="457200" cy="0"/>
+          </a:xfrm>
+          <a:prstGeom prst="line">
+            <a:avLst/>
+          </a:prstGeom>
+          <a:ln w="25400">
+            <a:solidFill>
+              <a:srgbClr val="5C6773"/>
+            </a:solidFill>
+          </a:ln>
+        </p:spPr>
+        <p:style>
+          <a:lnRef idx="2">
+            <a:schemeClr val="accent1"/>
+          </a:lnRef>
+          <a:fillRef idx="0">
+            <a:schemeClr val="accent1"/>
+          </a:fillRef>
+          <a:effectRef idx="1">
+            <a:schemeClr val="accent1"/>
+          </a:effectRef>
+          <a:fontRef idx="minor">
+            <a:schemeClr val="tx1"/>
+          </a:fontRef>
+        </p:style>
+      </p:cxnSp>
+      <p:cxnSp>
+        <p:nvCxnSpPr>
           <p:cNvPr id="12" name="Connector 11"/>
           <p:cNvCxnSpPr/>
           <p:nvPr/>
         </p:nvCxnSpPr>
         <p:spPr>
-          <a:xfrm>
-            <a:off x="2788920" y="1755648"/>
-            <a:ext cx="457200" cy="0"/>
+          <a:xfrm flipV="1">
+            <a:off x="4892040" y="1280160"/>
+            <a:ext cx="594360" cy="475488"/>
           </a:xfrm>
           <a:prstGeom prst="line">
             <a:avLst/>
@@ -12039,8 +11832,8 @@
         </p:nvCxnSpPr>
         <p:spPr>
           <a:xfrm flipV="1">
-            <a:off x="4892040" y="1280160"/>
-            <a:ext cx="594360" cy="475488"/>
+            <a:off x="4892040" y="2286000"/>
+            <a:ext cx="594360" cy="1207008"/>
           </a:xfrm>
           <a:prstGeom prst="line">
             <a:avLst/>
@@ -12074,8 +11867,8 @@
         </p:nvCxnSpPr>
         <p:spPr>
           <a:xfrm flipV="1">
-            <a:off x="4892040" y="2286000"/>
-            <a:ext cx="594360" cy="1207008"/>
+            <a:off x="4892040" y="3291840"/>
+            <a:ext cx="594360" cy="201168"/>
           </a:xfrm>
           <a:prstGeom prst="line">
             <a:avLst/>
@@ -12108,9 +11901,9 @@
           <p:nvPr/>
         </p:nvCxnSpPr>
         <p:spPr>
-          <a:xfrm flipV="1">
-            <a:off x="4892040" y="3291840"/>
-            <a:ext cx="594360" cy="201168"/>
+          <a:xfrm>
+            <a:off x="7040880" y="2331720"/>
+            <a:ext cx="594360" cy="365760"/>
           </a:xfrm>
           <a:prstGeom prst="line">
             <a:avLst/>
@@ -12136,44 +11929,9 @@
           </a:fontRef>
         </p:style>
       </p:cxnSp>
-      <p:cxnSp>
-        <p:nvCxnSpPr>
-          <p:cNvPr id="16" name="Connector 15"/>
-          <p:cNvCxnSpPr/>
-          <p:nvPr/>
-        </p:nvCxnSpPr>
-        <p:spPr>
-          <a:xfrm>
-            <a:off x="7040880" y="2331720"/>
-            <a:ext cx="594360" cy="365760"/>
-          </a:xfrm>
-          <a:prstGeom prst="line">
-            <a:avLst/>
-          </a:prstGeom>
-          <a:ln w="25400">
-            <a:solidFill>
-              <a:srgbClr val="5C6773"/>
-            </a:solidFill>
-          </a:ln>
-        </p:spPr>
-        <p:style>
-          <a:lnRef idx="2">
-            <a:schemeClr val="accent1"/>
-          </a:lnRef>
-          <a:fillRef idx="0">
-            <a:schemeClr val="accent1"/>
-          </a:fillRef>
-          <a:effectRef idx="1">
-            <a:schemeClr val="accent1"/>
-          </a:effectRef>
-          <a:fontRef idx="minor">
-            <a:schemeClr val="tx1"/>
-          </a:fontRef>
-        </p:style>
-      </p:cxnSp>
-      <p:sp>
-        <p:nvSpPr>
-          <p:cNvPr id="17" name="TextBox 16"/>
+      <p:sp>
+        <p:nvSpPr>
+          <p:cNvPr id="16" name="TextBox 15"/>
           <p:cNvSpPr txBox="1"/>
           <p:nvPr/>
         </p:nvSpPr>

</xml_diff>

<commit_message>
Add references and stream figures to slide deck
</commit_message>
<xml_diff>
--- a/docs/stream_project_slide_deck.pptx
+++ b/docs/stream_project_slide_deck.pptx
@@ -17,6 +17,8 @@
     <p:sldId id="265" r:id="rId16"/>
     <p:sldId id="266" r:id="rId17"/>
     <p:sldId id="267" r:id="rId18"/>
+    <p:sldId id="268" r:id="rId19"/>
+    <p:sldId id="269" r:id="rId20"/>
   </p:sldIdLst>
   <p:sldSz cx="12191695" cy="6858000" type="screen4x3"/>
   <p:notesSz cx="6858000" cy="9144000"/>
@@ -4054,47 +4056,132 @@
                 </a:solidFill>
                 <a:latin typeface="Aptos"/>
               </a:rPr>
-              <a:t>Zebrafish transfer is challenging: fine-tuning is best learned model in relative time</a:t>
-            </a:r>
-          </a:p>
-        </p:txBody>
-      </p:sp>
-      <p:pic>
-        <p:nvPicPr>
-          <p:cNvPr id="3" name="Picture 2" descr="zfish_transfer.png"/>
-          <p:cNvPicPr>
-            <a:picLocks noChangeAspect="1"/>
-          </p:cNvPicPr>
-          <p:nvPr/>
-        </p:nvPicPr>
-        <p:blipFill>
-          <a:blip r:embed="rId2"/>
-          <a:stretch>
-            <a:fillRect/>
-          </a:stretch>
-        </p:blipFill>
-        <p:spPr>
-          <a:xfrm>
-            <a:off x="777240" y="1195753"/>
-            <a:ext cx="7863840" cy="3780692"/>
-          </a:xfrm>
-          <a:prstGeom prst="rect">
-            <a:avLst/>
-          </a:prstGeom>
-        </p:spPr>
-      </p:pic>
-      <p:sp>
-        <p:nvSpPr>
-          <p:cNvPr id="4" name="Rectangle 3"/>
+              <a:t>Cross-species transfer swaps the genome and cell-state vocabulary, not the training objective</a:t>
+            </a:r>
+          </a:p>
+        </p:txBody>
+      </p:sp>
+      <p:sp>
+        <p:nvSpPr>
+          <p:cNvPr id="3" name="Rounded Rectangle 2"/>
           <p:cNvSpPr/>
           <p:nvPr/>
         </p:nvSpPr>
         <p:spPr>
           <a:xfrm>
-            <a:off x="8961120" y="1234440"/>
-            <a:ext cx="2103120" cy="868680"/>
-          </a:xfrm>
-          <a:prstGeom prst="rect">
+            <a:off x="777240" y="1325880"/>
+            <a:ext cx="2011680" cy="868680"/>
+          </a:xfrm>
+          <a:prstGeom prst="roundRect">
+            <a:avLst/>
+          </a:prstGeom>
+          <a:solidFill>
+            <a:srgbClr val="E1EBF7"/>
+          </a:solidFill>
+          <a:ln w="13970">
+            <a:solidFill>
+              <a:srgbClr val="3165A3"/>
+            </a:solidFill>
+          </a:ln>
+        </p:spPr>
+        <p:style>
+          <a:lnRef idx="1">
+            <a:schemeClr val="accent1"/>
+          </a:lnRef>
+          <a:fillRef idx="3">
+            <a:schemeClr val="accent1"/>
+          </a:fillRef>
+          <a:effectRef idx="2">
+            <a:schemeClr val="accent1"/>
+          </a:effectRef>
+          <a:fontRef idx="minor">
+            <a:schemeClr val="lt1"/>
+          </a:fontRef>
+        </p:style>
+        <p:txBody>
+          <a:bodyPr rtlCol="0" anchor="ctr" lIns="73152" rIns="73152" tIns="54864" bIns="54864"/>
+          <a:lstStyle/>
+          <a:p>
+            <a:pPr algn="ctr"/>
+            <a:r>
+              <a:rPr sz="1300" b="1">
+                <a:solidFill>
+                  <a:srgbClr val="20252A"/>
+                </a:solidFill>
+                <a:latin typeface="Aptos"/>
+              </a:rPr>
+              <a:t>mouse 10k
+UCE cross-attn</a:t>
+            </a:r>
+          </a:p>
+        </p:txBody>
+      </p:sp>
+      <p:sp>
+        <p:nvSpPr>
+          <p:cNvPr id="4" name="Rounded Rectangle 3"/>
+          <p:cNvSpPr/>
+          <p:nvPr/>
+        </p:nvSpPr>
+        <p:spPr>
+          <a:xfrm>
+            <a:off x="3246120" y="1325880"/>
+            <a:ext cx="1645920" cy="868680"/>
+          </a:xfrm>
+          <a:prstGeom prst="roundRect">
+            <a:avLst/>
+          </a:prstGeom>
+          <a:solidFill>
+            <a:srgbClr val="FFFFFF"/>
+          </a:solidFill>
+          <a:ln w="13970">
+            <a:solidFill>
+              <a:srgbClr val="3165A3"/>
+            </a:solidFill>
+          </a:ln>
+        </p:spPr>
+        <p:style>
+          <a:lnRef idx="1">
+            <a:schemeClr val="accent1"/>
+          </a:lnRef>
+          <a:fillRef idx="3">
+            <a:schemeClr val="accent1"/>
+          </a:fillRef>
+          <a:effectRef idx="2">
+            <a:schemeClr val="accent1"/>
+          </a:effectRef>
+          <a:fontRef idx="minor">
+            <a:schemeClr val="lt1"/>
+          </a:fontRef>
+        </p:style>
+        <p:txBody>
+          <a:bodyPr rtlCol="0" anchor="ctr" lIns="73152" rIns="73152" tIns="54864" bIns="54864"/>
+          <a:lstStyle/>
+          <a:p>
+            <a:pPr algn="ctr"/>
+            <a:r>
+              <a:rPr sz="1300" b="1">
+                <a:solidFill>
+                  <a:srgbClr val="20252A"/>
+                </a:solidFill>
+                <a:latin typeface="Aptos"/>
+              </a:rPr>
+              <a:t>source checkpoint</a:t>
+            </a:r>
+          </a:p>
+        </p:txBody>
+      </p:sp>
+      <p:sp>
+        <p:nvSpPr>
+          <p:cNvPr id="5" name="Rounded Rectangle 4"/>
+          <p:cNvSpPr/>
+          <p:nvPr/>
+        </p:nvSpPr>
+        <p:spPr>
+          <a:xfrm>
+            <a:off x="777240" y="3063240"/>
+            <a:ext cx="2011680" cy="868680"/>
+          </a:xfrm>
+          <a:prstGeom prst="roundRect">
             <a:avLst/>
           </a:prstGeom>
           <a:solidFill>
@@ -4102,7 +4189,7 @@
           </a:solidFill>
           <a:ln w="13970">
             <a:solidFill>
-              <a:srgbClr val="D2D8DE"/>
+              <a:srgbClr val="539A5D"/>
             </a:solidFill>
           </a:ln>
         </p:spPr>
@@ -4126,99 +4213,193 @@
           <a:p>
             <a:pPr algn="ctr"/>
             <a:r>
-              <a:rPr sz="1300" b="0">
+              <a:rPr sz="1300" b="1">
                 <a:solidFill>
                   <a:srgbClr val="20252A"/>
                 </a:solidFill>
                 <a:latin typeface="Aptos"/>
               </a:rPr>
-              <a:t/>
-            </a:r>
-          </a:p>
-        </p:txBody>
-      </p:sp>
-      <p:sp>
-        <p:nvSpPr>
-          <p:cNvPr id="5" name="TextBox 4"/>
-          <p:cNvSpPr txBox="1"/>
-          <p:nvPr/>
-        </p:nvSpPr>
-        <p:spPr>
-          <a:xfrm>
-            <a:off x="9015984" y="1362456"/>
-            <a:ext cx="1993391" cy="329184"/>
-          </a:xfrm>
-          <a:prstGeom prst="rect">
-            <a:avLst/>
-          </a:prstGeom>
-          <a:noFill/>
-        </p:spPr>
-        <p:txBody>
-          <a:bodyPr wrap="none" lIns="36576" rIns="36576" tIns="18288" bIns="18288" anchor="t">
-            <a:spAutoFit/>
-          </a:bodyPr>
+              <a:t>zebrafish UCE
+cell states</a:t>
+            </a:r>
+          </a:p>
+        </p:txBody>
+      </p:sp>
+      <p:sp>
+        <p:nvSpPr>
+          <p:cNvPr id="6" name="Rounded Rectangle 5"/>
+          <p:cNvSpPr/>
+          <p:nvPr/>
+        </p:nvSpPr>
+        <p:spPr>
+          <a:xfrm>
+            <a:off x="3246120" y="3063240"/>
+            <a:ext cx="1645920" cy="868680"/>
+          </a:xfrm>
+          <a:prstGeom prst="roundRect">
+            <a:avLst/>
+          </a:prstGeom>
+          <a:solidFill>
+            <a:srgbClr val="F9EECF"/>
+          </a:solidFill>
+          <a:ln w="13970">
+            <a:solidFill>
+              <a:srgbClr val="D69E2E"/>
+            </a:solidFill>
+          </a:ln>
+        </p:spPr>
+        <p:style>
+          <a:lnRef idx="1">
+            <a:schemeClr val="accent1"/>
+          </a:lnRef>
+          <a:fillRef idx="3">
+            <a:schemeClr val="accent1"/>
+          </a:fillRef>
+          <a:effectRef idx="2">
+            <a:schemeClr val="accent1"/>
+          </a:effectRef>
+          <a:fontRef idx="minor">
+            <a:schemeClr val="lt1"/>
+          </a:fontRef>
+        </p:style>
+        <p:txBody>
+          <a:bodyPr rtlCol="0" anchor="ctr" lIns="73152" rIns="73152" tIns="54864" bIns="54864"/>
           <a:lstStyle/>
           <a:p>
             <a:pPr algn="ctr"/>
             <a:r>
-              <a:rPr sz="2300" b="1">
+              <a:rPr sz="1300" b="1">
                 <a:solidFill>
                   <a:srgbClr val="20252A"/>
                 </a:solidFill>
                 <a:latin typeface="Aptos"/>
               </a:rPr>
-              <a:t>0.131</a:t>
-            </a:r>
-          </a:p>
-        </p:txBody>
-      </p:sp>
-      <p:sp>
-        <p:nvSpPr>
-          <p:cNvPr id="6" name="TextBox 5"/>
-          <p:cNvSpPr txBox="1"/>
-          <p:nvPr/>
-        </p:nvSpPr>
-        <p:spPr>
-          <a:xfrm>
-            <a:off x="9034272" y="1764792"/>
-            <a:ext cx="1956815" cy="365760"/>
-          </a:xfrm>
-          <a:prstGeom prst="rect">
-            <a:avLst/>
-          </a:prstGeom>
-          <a:noFill/>
-        </p:spPr>
-        <p:txBody>
-          <a:bodyPr wrap="none" lIns="36576" rIns="36576" tIns="18288" bIns="18288" anchor="t">
-            <a:spAutoFit/>
-          </a:bodyPr>
+              <a:t>zebrafish cCRE
+sequence tokens</a:t>
+            </a:r>
+          </a:p>
+        </p:txBody>
+      </p:sp>
+      <p:sp>
+        <p:nvSpPr>
+          <p:cNvPr id="7" name="Rounded Rectangle 6"/>
+          <p:cNvSpPr/>
+          <p:nvPr/>
+        </p:nvSpPr>
+        <p:spPr>
+          <a:xfrm>
+            <a:off x="5486400" y="960120"/>
+            <a:ext cx="1554480" cy="640080"/>
+          </a:xfrm>
+          <a:prstGeom prst="roundRect">
+            <a:avLst/>
+          </a:prstGeom>
+          <a:solidFill>
+            <a:srgbClr val="F9EECF"/>
+          </a:solidFill>
+          <a:ln w="13970">
+            <a:solidFill>
+              <a:srgbClr val="D69E2E"/>
+            </a:solidFill>
+          </a:ln>
+        </p:spPr>
+        <p:style>
+          <a:lnRef idx="1">
+            <a:schemeClr val="accent1"/>
+          </a:lnRef>
+          <a:fillRef idx="3">
+            <a:schemeClr val="accent1"/>
+          </a:fillRef>
+          <a:effectRef idx="2">
+            <a:schemeClr val="accent1"/>
+          </a:effectRef>
+          <a:fontRef idx="minor">
+            <a:schemeClr val="lt1"/>
+          </a:fontRef>
+        </p:style>
+        <p:txBody>
+          <a:bodyPr rtlCol="0" anchor="ctr" lIns="73152" rIns="73152" tIns="54864" bIns="54864"/>
           <a:lstStyle/>
           <a:p>
             <a:pPr algn="ctr"/>
             <a:r>
-              <a:rPr sz="1000" b="0">
-                <a:solidFill>
-                  <a:srgbClr val="5C6773"/>
+              <a:rPr sz="1300" b="1">
+                <a:solidFill>
+                  <a:srgbClr val="20252A"/>
                 </a:solidFill>
                 <a:latin typeface="Aptos"/>
               </a:rPr>
-              <a:t>relative fine-tuned</a:t>
-            </a:r>
-          </a:p>
-        </p:txBody>
-      </p:sp>
-      <p:sp>
-        <p:nvSpPr>
-          <p:cNvPr id="7" name="Rectangle 6"/>
+              <a:t>zero-shot</a:t>
+            </a:r>
+          </a:p>
+        </p:txBody>
+      </p:sp>
+      <p:sp>
+        <p:nvSpPr>
+          <p:cNvPr id="8" name="Rounded Rectangle 7"/>
           <p:cNvSpPr/>
           <p:nvPr/>
         </p:nvSpPr>
         <p:spPr>
           <a:xfrm>
-            <a:off x="8961120" y="2468880"/>
-            <a:ext cx="2103120" cy="868680"/>
-          </a:xfrm>
-          <a:prstGeom prst="rect">
+            <a:off x="5486400" y="1965960"/>
+            <a:ext cx="1554480" cy="640080"/>
+          </a:xfrm>
+          <a:prstGeom prst="roundRect">
+            <a:avLst/>
+          </a:prstGeom>
+          <a:solidFill>
+            <a:srgbClr val="E0F1E5"/>
+          </a:solidFill>
+          <a:ln w="13970">
+            <a:solidFill>
+              <a:srgbClr val="539A5D"/>
+            </a:solidFill>
+          </a:ln>
+        </p:spPr>
+        <p:style>
+          <a:lnRef idx="1">
+            <a:schemeClr val="accent1"/>
+          </a:lnRef>
+          <a:fillRef idx="3">
+            <a:schemeClr val="accent1"/>
+          </a:fillRef>
+          <a:effectRef idx="2">
+            <a:schemeClr val="accent1"/>
+          </a:effectRef>
+          <a:fontRef idx="minor">
+            <a:schemeClr val="lt1"/>
+          </a:fontRef>
+        </p:style>
+        <p:txBody>
+          <a:bodyPr rtlCol="0" anchor="ctr" lIns="73152" rIns="73152" tIns="54864" bIns="54864"/>
+          <a:lstStyle/>
+          <a:p>
+            <a:pPr algn="ctr"/>
+            <a:r>
+              <a:rPr sz="1300" b="1">
+                <a:solidFill>
+                  <a:srgbClr val="20252A"/>
+                </a:solidFill>
+                <a:latin typeface="Aptos"/>
+              </a:rPr>
+              <a:t>fine-tuned</a:t>
+            </a:r>
+          </a:p>
+        </p:txBody>
+      </p:sp>
+      <p:sp>
+        <p:nvSpPr>
+          <p:cNvPr id="9" name="Rounded Rectangle 8"/>
+          <p:cNvSpPr/>
+          <p:nvPr/>
+        </p:nvSpPr>
+        <p:spPr>
+          <a:xfrm>
+            <a:off x="5486400" y="2971800"/>
+            <a:ext cx="1554480" cy="640080"/>
+          </a:xfrm>
+          <a:prstGeom prst="roundRect">
             <a:avLst/>
           </a:prstGeom>
           <a:solidFill>
@@ -4226,7 +4407,7 @@
           </a:solidFill>
           <a:ln w="13970">
             <a:solidFill>
-              <a:srgbClr val="D2D8DE"/>
+              <a:srgbClr val="3165A3"/>
             </a:solidFill>
           </a:ln>
         </p:spPr>
@@ -4250,107 +4431,37 @@
           <a:p>
             <a:pPr algn="ctr"/>
             <a:r>
-              <a:rPr sz="1300" b="0">
+              <a:rPr sz="1300" b="1">
                 <a:solidFill>
                   <a:srgbClr val="20252A"/>
                 </a:solidFill>
                 <a:latin typeface="Aptos"/>
               </a:rPr>
-              <a:t/>
-            </a:r>
-          </a:p>
-        </p:txBody>
-      </p:sp>
-      <p:sp>
-        <p:nvSpPr>
-          <p:cNvPr id="8" name="TextBox 7"/>
-          <p:cNvSpPr txBox="1"/>
-          <p:nvPr/>
-        </p:nvSpPr>
-        <p:spPr>
-          <a:xfrm>
-            <a:off x="9015984" y="2596896"/>
-            <a:ext cx="1993391" cy="329184"/>
-          </a:xfrm>
-          <a:prstGeom prst="rect">
-            <a:avLst/>
-          </a:prstGeom>
-          <a:noFill/>
-        </p:spPr>
-        <p:txBody>
-          <a:bodyPr wrap="none" lIns="36576" rIns="36576" tIns="18288" bIns="18288" anchor="t">
-            <a:spAutoFit/>
-          </a:bodyPr>
-          <a:lstStyle/>
-          <a:p>
-            <a:pPr algn="ctr"/>
-            <a:r>
-              <a:rPr sz="2300" b="1">
-                <a:solidFill>
-                  <a:srgbClr val="20252A"/>
-                </a:solidFill>
-                <a:latin typeface="Aptos"/>
-              </a:rPr>
-              <a:t>0.157</a:t>
-            </a:r>
-          </a:p>
-        </p:txBody>
-      </p:sp>
-      <p:sp>
-        <p:nvSpPr>
-          <p:cNvPr id="9" name="TextBox 8"/>
-          <p:cNvSpPr txBox="1"/>
-          <p:nvPr/>
-        </p:nvSpPr>
-        <p:spPr>
-          <a:xfrm>
-            <a:off x="9034272" y="2999232"/>
-            <a:ext cx="1956815" cy="365760"/>
-          </a:xfrm>
-          <a:prstGeom prst="rect">
-            <a:avLst/>
-          </a:prstGeom>
-          <a:noFill/>
-        </p:spPr>
-        <p:txBody>
-          <a:bodyPr wrap="none" lIns="36576" rIns="36576" tIns="18288" bIns="18288" anchor="t">
-            <a:spAutoFit/>
-          </a:bodyPr>
-          <a:lstStyle/>
-          <a:p>
-            <a:pPr algn="ctr"/>
-            <a:r>
-              <a:rPr sz="1000" b="0">
-                <a:solidFill>
-                  <a:srgbClr val="5C6773"/>
-                </a:solidFill>
-                <a:latin typeface="Aptos"/>
-              </a:rPr>
-              <a:t>relative zebrafish only</a:t>
-            </a:r>
-          </a:p>
-        </p:txBody>
-      </p:sp>
-      <p:sp>
-        <p:nvSpPr>
-          <p:cNvPr id="10" name="Rectangle 9"/>
+              <a:t>zebrafish only</a:t>
+            </a:r>
+          </a:p>
+        </p:txBody>
+      </p:sp>
+      <p:sp>
+        <p:nvSpPr>
+          <p:cNvPr id="10" name="Rounded Rectangle 9"/>
           <p:cNvSpPr/>
           <p:nvPr/>
         </p:nvSpPr>
         <p:spPr>
           <a:xfrm>
-            <a:off x="8961120" y="3703320"/>
-            <a:ext cx="2103120" cy="868680"/>
-          </a:xfrm>
-          <a:prstGeom prst="rect">
+            <a:off x="7635240" y="2240280"/>
+            <a:ext cx="3017520" cy="960120"/>
+          </a:xfrm>
+          <a:prstGeom prst="roundRect">
             <a:avLst/>
           </a:prstGeom>
           <a:solidFill>
-            <a:srgbClr val="F9EECF"/>
+            <a:srgbClr val="FFFFFF"/>
           </a:solidFill>
           <a:ln w="13970">
             <a:solidFill>
-              <a:srgbClr val="D2D8DE"/>
+              <a:srgbClr val="BE4B49"/>
             </a:solidFill>
           </a:ln>
         </p:spPr>
@@ -4374,27 +4485,203 @@
           <a:p>
             <a:pPr algn="ctr"/>
             <a:r>
-              <a:rPr sz="1300" b="0">
+              <a:rPr sz="1300" b="1">
                 <a:solidFill>
                   <a:srgbClr val="20252A"/>
                 </a:solidFill>
                 <a:latin typeface="Aptos"/>
               </a:rPr>
-              <a:t/>
-            </a:r>
-          </a:p>
-        </p:txBody>
-      </p:sp>
-      <p:sp>
-        <p:nvSpPr>
-          <p:cNvPr id="11" name="TextBox 10"/>
+              <a:t>held-out 36 and 72 hpf
+expression displacement</a:t>
+            </a:r>
+          </a:p>
+        </p:txBody>
+      </p:sp>
+      <p:cxnSp>
+        <p:nvCxnSpPr>
+          <p:cNvPr id="11" name="Connector 10"/>
+          <p:cNvCxnSpPr/>
+          <p:nvPr/>
+        </p:nvCxnSpPr>
+        <p:spPr>
+          <a:xfrm>
+            <a:off x="2788920" y="1755648"/>
+            <a:ext cx="457200" cy="0"/>
+          </a:xfrm>
+          <a:prstGeom prst="line">
+            <a:avLst/>
+          </a:prstGeom>
+          <a:ln w="25400">
+            <a:solidFill>
+              <a:srgbClr val="5C6773"/>
+            </a:solidFill>
+          </a:ln>
+        </p:spPr>
+        <p:style>
+          <a:lnRef idx="2">
+            <a:schemeClr val="accent1"/>
+          </a:lnRef>
+          <a:fillRef idx="0">
+            <a:schemeClr val="accent1"/>
+          </a:fillRef>
+          <a:effectRef idx="1">
+            <a:schemeClr val="accent1"/>
+          </a:effectRef>
+          <a:fontRef idx="minor">
+            <a:schemeClr val="tx1"/>
+          </a:fontRef>
+        </p:style>
+      </p:cxnSp>
+      <p:cxnSp>
+        <p:nvCxnSpPr>
+          <p:cNvPr id="12" name="Connector 11"/>
+          <p:cNvCxnSpPr/>
+          <p:nvPr/>
+        </p:nvCxnSpPr>
+        <p:spPr>
+          <a:xfrm flipV="1">
+            <a:off x="4892040" y="1280160"/>
+            <a:ext cx="594360" cy="475488"/>
+          </a:xfrm>
+          <a:prstGeom prst="line">
+            <a:avLst/>
+          </a:prstGeom>
+          <a:ln w="25400">
+            <a:solidFill>
+              <a:srgbClr val="5C6773"/>
+            </a:solidFill>
+          </a:ln>
+        </p:spPr>
+        <p:style>
+          <a:lnRef idx="2">
+            <a:schemeClr val="accent1"/>
+          </a:lnRef>
+          <a:fillRef idx="0">
+            <a:schemeClr val="accent1"/>
+          </a:fillRef>
+          <a:effectRef idx="1">
+            <a:schemeClr val="accent1"/>
+          </a:effectRef>
+          <a:fontRef idx="minor">
+            <a:schemeClr val="tx1"/>
+          </a:fontRef>
+        </p:style>
+      </p:cxnSp>
+      <p:cxnSp>
+        <p:nvCxnSpPr>
+          <p:cNvPr id="13" name="Connector 12"/>
+          <p:cNvCxnSpPr/>
+          <p:nvPr/>
+        </p:nvCxnSpPr>
+        <p:spPr>
+          <a:xfrm flipV="1">
+            <a:off x="4892040" y="2286000"/>
+            <a:ext cx="594360" cy="1207008"/>
+          </a:xfrm>
+          <a:prstGeom prst="line">
+            <a:avLst/>
+          </a:prstGeom>
+          <a:ln w="25400">
+            <a:solidFill>
+              <a:srgbClr val="5C6773"/>
+            </a:solidFill>
+          </a:ln>
+        </p:spPr>
+        <p:style>
+          <a:lnRef idx="2">
+            <a:schemeClr val="accent1"/>
+          </a:lnRef>
+          <a:fillRef idx="0">
+            <a:schemeClr val="accent1"/>
+          </a:fillRef>
+          <a:effectRef idx="1">
+            <a:schemeClr val="accent1"/>
+          </a:effectRef>
+          <a:fontRef idx="minor">
+            <a:schemeClr val="tx1"/>
+          </a:fontRef>
+        </p:style>
+      </p:cxnSp>
+      <p:cxnSp>
+        <p:nvCxnSpPr>
+          <p:cNvPr id="14" name="Connector 13"/>
+          <p:cNvCxnSpPr/>
+          <p:nvPr/>
+        </p:nvCxnSpPr>
+        <p:spPr>
+          <a:xfrm flipV="1">
+            <a:off x="4892040" y="3291840"/>
+            <a:ext cx="594360" cy="201168"/>
+          </a:xfrm>
+          <a:prstGeom prst="line">
+            <a:avLst/>
+          </a:prstGeom>
+          <a:ln w="25400">
+            <a:solidFill>
+              <a:srgbClr val="5C6773"/>
+            </a:solidFill>
+          </a:ln>
+        </p:spPr>
+        <p:style>
+          <a:lnRef idx="2">
+            <a:schemeClr val="accent1"/>
+          </a:lnRef>
+          <a:fillRef idx="0">
+            <a:schemeClr val="accent1"/>
+          </a:fillRef>
+          <a:effectRef idx="1">
+            <a:schemeClr val="accent1"/>
+          </a:effectRef>
+          <a:fontRef idx="minor">
+            <a:schemeClr val="tx1"/>
+          </a:fontRef>
+        </p:style>
+      </p:cxnSp>
+      <p:cxnSp>
+        <p:nvCxnSpPr>
+          <p:cNvPr id="15" name="Connector 14"/>
+          <p:cNvCxnSpPr/>
+          <p:nvPr/>
+        </p:nvCxnSpPr>
+        <p:spPr>
+          <a:xfrm>
+            <a:off x="7040880" y="2331720"/>
+            <a:ext cx="594360" cy="365760"/>
+          </a:xfrm>
+          <a:prstGeom prst="line">
+            <a:avLst/>
+          </a:prstGeom>
+          <a:ln w="25400">
+            <a:solidFill>
+              <a:srgbClr val="5C6773"/>
+            </a:solidFill>
+          </a:ln>
+        </p:spPr>
+        <p:style>
+          <a:lnRef idx="2">
+            <a:schemeClr val="accent1"/>
+          </a:lnRef>
+          <a:fillRef idx="0">
+            <a:schemeClr val="accent1"/>
+          </a:fillRef>
+          <a:effectRef idx="1">
+            <a:schemeClr val="accent1"/>
+          </a:effectRef>
+          <a:fontRef idx="minor">
+            <a:schemeClr val="tx1"/>
+          </a:fontRef>
+        </p:style>
+      </p:cxnSp>
+      <p:sp>
+        <p:nvSpPr>
+          <p:cNvPr id="16" name="TextBox 15"/>
           <p:cNvSpPr txBox="1"/>
           <p:nvPr/>
         </p:nvSpPr>
         <p:spPr>
           <a:xfrm>
-            <a:off x="9015984" y="3831335"/>
-            <a:ext cx="1993391" cy="329184"/>
+            <a:off x="1005840" y="5212080"/>
+            <a:ext cx="9966960" cy="411480"/>
           </a:xfrm>
           <a:prstGeom prst="rect">
             <a:avLst/>
@@ -4409,83 +4696,13 @@
           <a:p>
             <a:pPr algn="ctr"/>
             <a:r>
-              <a:rPr sz="2300" b="1">
+              <a:rPr sz="1500" b="1">
                 <a:solidFill>
                   <a:srgbClr val="20252A"/>
                 </a:solidFill>
                 <a:latin typeface="Aptos"/>
               </a:rPr>
-              <a:t>0.175</a:t>
-            </a:r>
-          </a:p>
-        </p:txBody>
-      </p:sp>
-      <p:sp>
-        <p:nvSpPr>
-          <p:cNvPr id="12" name="TextBox 11"/>
-          <p:cNvSpPr txBox="1"/>
-          <p:nvPr/>
-        </p:nvSpPr>
-        <p:spPr>
-          <a:xfrm>
-            <a:off x="9034272" y="4233672"/>
-            <a:ext cx="1956815" cy="365760"/>
-          </a:xfrm>
-          <a:prstGeom prst="rect">
-            <a:avLst/>
-          </a:prstGeom>
-          <a:noFill/>
-        </p:spPr>
-        <p:txBody>
-          <a:bodyPr wrap="none" lIns="36576" rIns="36576" tIns="18288" bIns="18288" anchor="t">
-            <a:spAutoFit/>
-          </a:bodyPr>
-          <a:lstStyle/>
-          <a:p>
-            <a:pPr algn="ctr"/>
-            <a:r>
-              <a:rPr sz="1000" b="0">
-                <a:solidFill>
-                  <a:srgbClr val="5C6773"/>
-                </a:solidFill>
-                <a:latin typeface="Aptos"/>
-              </a:rPr>
-              <a:t>physical zero-shot</a:t>
-            </a:r>
-          </a:p>
-        </p:txBody>
-      </p:sp>
-      <p:sp>
-        <p:nvSpPr>
-          <p:cNvPr id="13" name="TextBox 12"/>
-          <p:cNvSpPr txBox="1"/>
-          <p:nvPr/>
-        </p:nvSpPr>
-        <p:spPr>
-          <a:xfrm>
-            <a:off x="914400" y="5669280"/>
-            <a:ext cx="10241280" cy="320040"/>
-          </a:xfrm>
-          <a:prstGeom prst="rect">
-            <a:avLst/>
-          </a:prstGeom>
-          <a:noFill/>
-        </p:spPr>
-        <p:txBody>
-          <a:bodyPr wrap="none" lIns="36576" rIns="36576" tIns="18288" bIns="18288" anchor="t">
-            <a:spAutoFit/>
-          </a:bodyPr>
-          <a:lstStyle/>
-          <a:p>
-            <a:pPr algn="ctr"/>
-            <a:r>
-              <a:rPr sz="1200" b="0">
-                <a:solidFill>
-                  <a:srgbClr val="5C6773"/>
-                </a:solidFill>
-                <a:latin typeface="Aptos"/>
-              </a:rPr>
-              <a:t>Lower displacement MAE is better. Bars compare learned transfer and target-only regimes.</a:t>
+              <a:t>Two time conventions are evaluated: physical days and organism-relative [0,1] time.</a:t>
             </a:r>
           </a:p>
         </p:txBody>
@@ -4499,6 +4716,498 @@
 </file>
 
 <file path=ppt/slides/slide11.xml><?xml version="1.0" encoding="utf-8"?>
+<p:sld xmlns:a="http://schemas.openxmlformats.org/drawingml/2006/main" xmlns:p="http://schemas.openxmlformats.org/presentationml/2006/main" xmlns:r="http://schemas.openxmlformats.org/officeDocument/2006/relationships">
+  <p:cSld>
+    <p:bg>
+      <p:bgPr>
+        <a:solidFill>
+          <a:srgbClr val="F8F9FA"/>
+        </a:solidFill>
+        <a:effectLst/>
+      </p:bgPr>
+    </p:bg>
+    <p:spTree>
+      <p:nvGrpSpPr>
+        <p:cNvPr id="1" name=""/>
+        <p:cNvGrpSpPr/>
+        <p:nvPr/>
+      </p:nvGrpSpPr>
+      <p:grpSpPr/>
+      <p:sp>
+        <p:nvSpPr>
+          <p:cNvPr id="2" name="TextBox 1"/>
+          <p:cNvSpPr txBox="1"/>
+          <p:nvPr/>
+        </p:nvSpPr>
+        <p:spPr>
+          <a:xfrm>
+            <a:off x="502920" y="237744"/>
+            <a:ext cx="11155680" cy="438912"/>
+          </a:xfrm>
+          <a:prstGeom prst="rect">
+            <a:avLst/>
+          </a:prstGeom>
+          <a:noFill/>
+        </p:spPr>
+        <p:txBody>
+          <a:bodyPr wrap="none" lIns="36576" rIns="36576" tIns="18288" bIns="18288" anchor="t">
+            <a:spAutoFit/>
+          </a:bodyPr>
+          <a:lstStyle/>
+          <a:p>
+            <a:pPr algn="l"/>
+            <a:r>
+              <a:rPr sz="2500" b="1">
+                <a:solidFill>
+                  <a:srgbClr val="20252A"/>
+                </a:solidFill>
+                <a:latin typeface="Aptos"/>
+              </a:rPr>
+              <a:t>Zebrafish transfer is challenging: fine-tuning is best learned model in relative time</a:t>
+            </a:r>
+          </a:p>
+        </p:txBody>
+      </p:sp>
+      <p:pic>
+        <p:nvPicPr>
+          <p:cNvPr id="3" name="Picture 2" descr="zfish_transfer.png"/>
+          <p:cNvPicPr>
+            <a:picLocks noChangeAspect="1"/>
+          </p:cNvPicPr>
+          <p:nvPr/>
+        </p:nvPicPr>
+        <p:blipFill>
+          <a:blip r:embed="rId2"/>
+          <a:stretch>
+            <a:fillRect/>
+          </a:stretch>
+        </p:blipFill>
+        <p:spPr>
+          <a:xfrm>
+            <a:off x="777240" y="1195753"/>
+            <a:ext cx="7863840" cy="3780692"/>
+          </a:xfrm>
+          <a:prstGeom prst="rect">
+            <a:avLst/>
+          </a:prstGeom>
+        </p:spPr>
+      </p:pic>
+      <p:sp>
+        <p:nvSpPr>
+          <p:cNvPr id="4" name="Rectangle 3"/>
+          <p:cNvSpPr/>
+          <p:nvPr/>
+        </p:nvSpPr>
+        <p:spPr>
+          <a:xfrm>
+            <a:off x="8961120" y="1234440"/>
+            <a:ext cx="2103120" cy="868680"/>
+          </a:xfrm>
+          <a:prstGeom prst="rect">
+            <a:avLst/>
+          </a:prstGeom>
+          <a:solidFill>
+            <a:srgbClr val="E0F1E5"/>
+          </a:solidFill>
+          <a:ln w="13970">
+            <a:solidFill>
+              <a:srgbClr val="D2D8DE"/>
+            </a:solidFill>
+          </a:ln>
+        </p:spPr>
+        <p:style>
+          <a:lnRef idx="1">
+            <a:schemeClr val="accent1"/>
+          </a:lnRef>
+          <a:fillRef idx="3">
+            <a:schemeClr val="accent1"/>
+          </a:fillRef>
+          <a:effectRef idx="2">
+            <a:schemeClr val="accent1"/>
+          </a:effectRef>
+          <a:fontRef idx="minor">
+            <a:schemeClr val="lt1"/>
+          </a:fontRef>
+        </p:style>
+        <p:txBody>
+          <a:bodyPr rtlCol="0" anchor="ctr" lIns="73152" rIns="73152" tIns="54864" bIns="54864"/>
+          <a:lstStyle/>
+          <a:p>
+            <a:pPr algn="ctr"/>
+            <a:r>
+              <a:rPr sz="1300" b="0">
+                <a:solidFill>
+                  <a:srgbClr val="20252A"/>
+                </a:solidFill>
+                <a:latin typeface="Aptos"/>
+              </a:rPr>
+              <a:t/>
+            </a:r>
+          </a:p>
+        </p:txBody>
+      </p:sp>
+      <p:sp>
+        <p:nvSpPr>
+          <p:cNvPr id="5" name="TextBox 4"/>
+          <p:cNvSpPr txBox="1"/>
+          <p:nvPr/>
+        </p:nvSpPr>
+        <p:spPr>
+          <a:xfrm>
+            <a:off x="9015984" y="1362456"/>
+            <a:ext cx="1993391" cy="329184"/>
+          </a:xfrm>
+          <a:prstGeom prst="rect">
+            <a:avLst/>
+          </a:prstGeom>
+          <a:noFill/>
+        </p:spPr>
+        <p:txBody>
+          <a:bodyPr wrap="none" lIns="36576" rIns="36576" tIns="18288" bIns="18288" anchor="t">
+            <a:spAutoFit/>
+          </a:bodyPr>
+          <a:lstStyle/>
+          <a:p>
+            <a:pPr algn="ctr"/>
+            <a:r>
+              <a:rPr sz="2300" b="1">
+                <a:solidFill>
+                  <a:srgbClr val="20252A"/>
+                </a:solidFill>
+                <a:latin typeface="Aptos"/>
+              </a:rPr>
+              <a:t>0.131</a:t>
+            </a:r>
+          </a:p>
+        </p:txBody>
+      </p:sp>
+      <p:sp>
+        <p:nvSpPr>
+          <p:cNvPr id="6" name="TextBox 5"/>
+          <p:cNvSpPr txBox="1"/>
+          <p:nvPr/>
+        </p:nvSpPr>
+        <p:spPr>
+          <a:xfrm>
+            <a:off x="9034272" y="1764792"/>
+            <a:ext cx="1956815" cy="365760"/>
+          </a:xfrm>
+          <a:prstGeom prst="rect">
+            <a:avLst/>
+          </a:prstGeom>
+          <a:noFill/>
+        </p:spPr>
+        <p:txBody>
+          <a:bodyPr wrap="none" lIns="36576" rIns="36576" tIns="18288" bIns="18288" anchor="t">
+            <a:spAutoFit/>
+          </a:bodyPr>
+          <a:lstStyle/>
+          <a:p>
+            <a:pPr algn="ctr"/>
+            <a:r>
+              <a:rPr sz="1000" b="0">
+                <a:solidFill>
+                  <a:srgbClr val="5C6773"/>
+                </a:solidFill>
+                <a:latin typeface="Aptos"/>
+              </a:rPr>
+              <a:t>relative fine-tuned</a:t>
+            </a:r>
+          </a:p>
+        </p:txBody>
+      </p:sp>
+      <p:sp>
+        <p:nvSpPr>
+          <p:cNvPr id="7" name="Rectangle 6"/>
+          <p:cNvSpPr/>
+          <p:nvPr/>
+        </p:nvSpPr>
+        <p:spPr>
+          <a:xfrm>
+            <a:off x="8961120" y="2468880"/>
+            <a:ext cx="2103120" cy="868680"/>
+          </a:xfrm>
+          <a:prstGeom prst="rect">
+            <a:avLst/>
+          </a:prstGeom>
+          <a:solidFill>
+            <a:srgbClr val="E1EBF7"/>
+          </a:solidFill>
+          <a:ln w="13970">
+            <a:solidFill>
+              <a:srgbClr val="D2D8DE"/>
+            </a:solidFill>
+          </a:ln>
+        </p:spPr>
+        <p:style>
+          <a:lnRef idx="1">
+            <a:schemeClr val="accent1"/>
+          </a:lnRef>
+          <a:fillRef idx="3">
+            <a:schemeClr val="accent1"/>
+          </a:fillRef>
+          <a:effectRef idx="2">
+            <a:schemeClr val="accent1"/>
+          </a:effectRef>
+          <a:fontRef idx="minor">
+            <a:schemeClr val="lt1"/>
+          </a:fontRef>
+        </p:style>
+        <p:txBody>
+          <a:bodyPr rtlCol="0" anchor="ctr" lIns="73152" rIns="73152" tIns="54864" bIns="54864"/>
+          <a:lstStyle/>
+          <a:p>
+            <a:pPr algn="ctr"/>
+            <a:r>
+              <a:rPr sz="1300" b="0">
+                <a:solidFill>
+                  <a:srgbClr val="20252A"/>
+                </a:solidFill>
+                <a:latin typeface="Aptos"/>
+              </a:rPr>
+              <a:t/>
+            </a:r>
+          </a:p>
+        </p:txBody>
+      </p:sp>
+      <p:sp>
+        <p:nvSpPr>
+          <p:cNvPr id="8" name="TextBox 7"/>
+          <p:cNvSpPr txBox="1"/>
+          <p:nvPr/>
+        </p:nvSpPr>
+        <p:spPr>
+          <a:xfrm>
+            <a:off x="9015984" y="2596896"/>
+            <a:ext cx="1993391" cy="329184"/>
+          </a:xfrm>
+          <a:prstGeom prst="rect">
+            <a:avLst/>
+          </a:prstGeom>
+          <a:noFill/>
+        </p:spPr>
+        <p:txBody>
+          <a:bodyPr wrap="none" lIns="36576" rIns="36576" tIns="18288" bIns="18288" anchor="t">
+            <a:spAutoFit/>
+          </a:bodyPr>
+          <a:lstStyle/>
+          <a:p>
+            <a:pPr algn="ctr"/>
+            <a:r>
+              <a:rPr sz="2300" b="1">
+                <a:solidFill>
+                  <a:srgbClr val="20252A"/>
+                </a:solidFill>
+                <a:latin typeface="Aptos"/>
+              </a:rPr>
+              <a:t>0.157</a:t>
+            </a:r>
+          </a:p>
+        </p:txBody>
+      </p:sp>
+      <p:sp>
+        <p:nvSpPr>
+          <p:cNvPr id="9" name="TextBox 8"/>
+          <p:cNvSpPr txBox="1"/>
+          <p:nvPr/>
+        </p:nvSpPr>
+        <p:spPr>
+          <a:xfrm>
+            <a:off x="9034272" y="2999232"/>
+            <a:ext cx="1956815" cy="365760"/>
+          </a:xfrm>
+          <a:prstGeom prst="rect">
+            <a:avLst/>
+          </a:prstGeom>
+          <a:noFill/>
+        </p:spPr>
+        <p:txBody>
+          <a:bodyPr wrap="none" lIns="36576" rIns="36576" tIns="18288" bIns="18288" anchor="t">
+            <a:spAutoFit/>
+          </a:bodyPr>
+          <a:lstStyle/>
+          <a:p>
+            <a:pPr algn="ctr"/>
+            <a:r>
+              <a:rPr sz="1000" b="0">
+                <a:solidFill>
+                  <a:srgbClr val="5C6773"/>
+                </a:solidFill>
+                <a:latin typeface="Aptos"/>
+              </a:rPr>
+              <a:t>relative zebrafish only</a:t>
+            </a:r>
+          </a:p>
+        </p:txBody>
+      </p:sp>
+      <p:sp>
+        <p:nvSpPr>
+          <p:cNvPr id="10" name="Rectangle 9"/>
+          <p:cNvSpPr/>
+          <p:nvPr/>
+        </p:nvSpPr>
+        <p:spPr>
+          <a:xfrm>
+            <a:off x="8961120" y="3703320"/>
+            <a:ext cx="2103120" cy="868680"/>
+          </a:xfrm>
+          <a:prstGeom prst="rect">
+            <a:avLst/>
+          </a:prstGeom>
+          <a:solidFill>
+            <a:srgbClr val="F9EECF"/>
+          </a:solidFill>
+          <a:ln w="13970">
+            <a:solidFill>
+              <a:srgbClr val="D2D8DE"/>
+            </a:solidFill>
+          </a:ln>
+        </p:spPr>
+        <p:style>
+          <a:lnRef idx="1">
+            <a:schemeClr val="accent1"/>
+          </a:lnRef>
+          <a:fillRef idx="3">
+            <a:schemeClr val="accent1"/>
+          </a:fillRef>
+          <a:effectRef idx="2">
+            <a:schemeClr val="accent1"/>
+          </a:effectRef>
+          <a:fontRef idx="minor">
+            <a:schemeClr val="lt1"/>
+          </a:fontRef>
+        </p:style>
+        <p:txBody>
+          <a:bodyPr rtlCol="0" anchor="ctr" lIns="73152" rIns="73152" tIns="54864" bIns="54864"/>
+          <a:lstStyle/>
+          <a:p>
+            <a:pPr algn="ctr"/>
+            <a:r>
+              <a:rPr sz="1300" b="0">
+                <a:solidFill>
+                  <a:srgbClr val="20252A"/>
+                </a:solidFill>
+                <a:latin typeface="Aptos"/>
+              </a:rPr>
+              <a:t/>
+            </a:r>
+          </a:p>
+        </p:txBody>
+      </p:sp>
+      <p:sp>
+        <p:nvSpPr>
+          <p:cNvPr id="11" name="TextBox 10"/>
+          <p:cNvSpPr txBox="1"/>
+          <p:nvPr/>
+        </p:nvSpPr>
+        <p:spPr>
+          <a:xfrm>
+            <a:off x="9015984" y="3831335"/>
+            <a:ext cx="1993391" cy="329184"/>
+          </a:xfrm>
+          <a:prstGeom prst="rect">
+            <a:avLst/>
+          </a:prstGeom>
+          <a:noFill/>
+        </p:spPr>
+        <p:txBody>
+          <a:bodyPr wrap="none" lIns="36576" rIns="36576" tIns="18288" bIns="18288" anchor="t">
+            <a:spAutoFit/>
+          </a:bodyPr>
+          <a:lstStyle/>
+          <a:p>
+            <a:pPr algn="ctr"/>
+            <a:r>
+              <a:rPr sz="2300" b="1">
+                <a:solidFill>
+                  <a:srgbClr val="20252A"/>
+                </a:solidFill>
+                <a:latin typeface="Aptos"/>
+              </a:rPr>
+              <a:t>0.175</a:t>
+            </a:r>
+          </a:p>
+        </p:txBody>
+      </p:sp>
+      <p:sp>
+        <p:nvSpPr>
+          <p:cNvPr id="12" name="TextBox 11"/>
+          <p:cNvSpPr txBox="1"/>
+          <p:nvPr/>
+        </p:nvSpPr>
+        <p:spPr>
+          <a:xfrm>
+            <a:off x="9034272" y="4233672"/>
+            <a:ext cx="1956815" cy="365760"/>
+          </a:xfrm>
+          <a:prstGeom prst="rect">
+            <a:avLst/>
+          </a:prstGeom>
+          <a:noFill/>
+        </p:spPr>
+        <p:txBody>
+          <a:bodyPr wrap="none" lIns="36576" rIns="36576" tIns="18288" bIns="18288" anchor="t">
+            <a:spAutoFit/>
+          </a:bodyPr>
+          <a:lstStyle/>
+          <a:p>
+            <a:pPr algn="ctr"/>
+            <a:r>
+              <a:rPr sz="1000" b="0">
+                <a:solidFill>
+                  <a:srgbClr val="5C6773"/>
+                </a:solidFill>
+                <a:latin typeface="Aptos"/>
+              </a:rPr>
+              <a:t>physical zero-shot</a:t>
+            </a:r>
+          </a:p>
+        </p:txBody>
+      </p:sp>
+      <p:sp>
+        <p:nvSpPr>
+          <p:cNvPr id="13" name="TextBox 12"/>
+          <p:cNvSpPr txBox="1"/>
+          <p:nvPr/>
+        </p:nvSpPr>
+        <p:spPr>
+          <a:xfrm>
+            <a:off x="914400" y="5669280"/>
+            <a:ext cx="10241280" cy="320040"/>
+          </a:xfrm>
+          <a:prstGeom prst="rect">
+            <a:avLst/>
+          </a:prstGeom>
+          <a:noFill/>
+        </p:spPr>
+        <p:txBody>
+          <a:bodyPr wrap="none" lIns="36576" rIns="36576" tIns="18288" bIns="18288" anchor="t">
+            <a:spAutoFit/>
+          </a:bodyPr>
+          <a:lstStyle/>
+          <a:p>
+            <a:pPr algn="ctr"/>
+            <a:r>
+              <a:rPr sz="1200" b="0">
+                <a:solidFill>
+                  <a:srgbClr val="5C6773"/>
+                </a:solidFill>
+                <a:latin typeface="Aptos"/>
+              </a:rPr>
+              <a:t>Lower displacement MAE is better. Bars compare learned transfer and target-only regimes.</a:t>
+            </a:r>
+          </a:p>
+        </p:txBody>
+      </p:sp>
+    </p:spTree>
+  </p:cSld>
+  <p:clrMapOvr>
+    <a:masterClrMapping/>
+  </p:clrMapOvr>
+</p:sld>
+</file>
+
+<file path=ppt/slides/slide12.xml><?xml version="1.0" encoding="utf-8"?>
 <p:sld xmlns:a="http://schemas.openxmlformats.org/drawingml/2006/main" xmlns:p="http://schemas.openxmlformats.org/presentationml/2006/main" xmlns:r="http://schemas.openxmlformats.org/officeDocument/2006/relationships">
   <p:cSld>
     <p:bg>
@@ -5407,7 +6116,7 @@
 </p:sld>
 </file>
 
-<file path=ppt/slides/slide12.xml><?xml version="1.0" encoding="utf-8"?>
+<file path=ppt/slides/slide13.xml><?xml version="1.0" encoding="utf-8"?>
 <p:sld xmlns:a="http://schemas.openxmlformats.org/drawingml/2006/main" xmlns:p="http://schemas.openxmlformats.org/presentationml/2006/main" xmlns:r="http://schemas.openxmlformats.org/officeDocument/2006/relationships">
   <p:cSld>
     <p:bg>
@@ -6089,6 +6798,470 @@
                 <a:latin typeface="Aptos"/>
               </a:rPr>
               <a:t>Main result: modeling more genes is helpful at 10k, especially when UCE state and cross-attention are combined.</a:t>
+            </a:r>
+          </a:p>
+        </p:txBody>
+      </p:sp>
+    </p:spTree>
+  </p:cSld>
+  <p:clrMapOvr>
+    <a:masterClrMapping/>
+  </p:clrMapOvr>
+</p:sld>
+</file>
+
+<file path=ppt/slides/slide14.xml><?xml version="1.0" encoding="utf-8"?>
+<p:sld xmlns:a="http://schemas.openxmlformats.org/drawingml/2006/main" xmlns:p="http://schemas.openxmlformats.org/presentationml/2006/main" xmlns:r="http://schemas.openxmlformats.org/officeDocument/2006/relationships">
+  <p:cSld>
+    <p:bg>
+      <p:bgPr>
+        <a:solidFill>
+          <a:srgbClr val="F8F9FA"/>
+        </a:solidFill>
+        <a:effectLst/>
+      </p:bgPr>
+    </p:bg>
+    <p:spTree>
+      <p:nvGrpSpPr>
+        <p:cNvPr id="1" name=""/>
+        <p:cNvGrpSpPr/>
+        <p:nvPr/>
+      </p:nvGrpSpPr>
+      <p:grpSpPr/>
+      <p:sp>
+        <p:nvSpPr>
+          <p:cNvPr id="2" name="TextBox 1"/>
+          <p:cNvSpPr txBox="1"/>
+          <p:nvPr/>
+        </p:nvSpPr>
+        <p:spPr>
+          <a:xfrm>
+            <a:off x="502920" y="237744"/>
+            <a:ext cx="11155680" cy="438912"/>
+          </a:xfrm>
+          <a:prstGeom prst="rect">
+            <a:avLst/>
+          </a:prstGeom>
+          <a:noFill/>
+        </p:spPr>
+        <p:txBody>
+          <a:bodyPr wrap="none" lIns="36576" rIns="36576" tIns="18288" bIns="18288" anchor="t">
+            <a:spAutoFit/>
+          </a:bodyPr>
+          <a:lstStyle/>
+          <a:p>
+            <a:pPr algn="l"/>
+            <a:r>
+              <a:rPr sz="2500" b="1">
+                <a:solidFill>
+                  <a:srgbClr val="20252A"/>
+                </a:solidFill>
+                <a:latin typeface="Aptos"/>
+              </a:rPr>
+              <a:t>References anchor the flow-matching, cell-embedding, sequence, and zebrafish components</a:t>
+            </a:r>
+          </a:p>
+        </p:txBody>
+      </p:sp>
+      <p:graphicFrame>
+        <p:nvGraphicFramePr>
+          <p:cNvPr id="3" name="Table 2"/>
+          <p:cNvGraphicFramePr>
+            <a:graphicFrameLocks noGrp="1"/>
+          </p:cNvGraphicFramePr>
+          <p:nvPr/>
+        </p:nvGraphicFramePr>
+        <p:xfrm>
+          <a:off x="594360" y="1051560"/>
+          <a:ext cx="10972800" cy="3063240"/>
+        </p:xfrm>
+        <a:graphic>
+          <a:graphicData uri="http://schemas.openxmlformats.org/drawingml/2006/table">
+            <a:tbl>
+              <a:tblPr firstRow="1" bandRow="1">
+                <a:tableStyleId>{5C22544A-7EE6-4342-B048-85BDC9FD1C3A}</a:tableStyleId>
+              </a:tblPr>
+              <a:tblGrid>
+                <a:gridCol w="5486400"/>
+                <a:gridCol w="5486400"/>
+              </a:tblGrid>
+              <a:tr h="510540">
+                <a:tc>
+                  <a:txBody>
+                    <a:bodyPr/>
+                    <a:lstStyle/>
+                    <a:p>
+                      <a:pPr algn="ctr"/>
+                      <a:r>
+                        <a:rPr sz="1000" b="1">
+                          <a:solidFill>
+                            <a:srgbClr val="FFFFFF"/>
+                          </a:solidFill>
+                          <a:latin typeface="Aptos"/>
+                        </a:rPr>
+                        <a:t>Component</a:t>
+                      </a:r>
+                    </a:p>
+                  </a:txBody>
+                  <a:tcPr>
+                    <a:solidFill>
+                      <a:srgbClr val="3165A3"/>
+                    </a:solidFill>
+                  </a:tcPr>
+                </a:tc>
+                <a:tc>
+                  <a:txBody>
+                    <a:bodyPr/>
+                    <a:lstStyle/>
+                    <a:p>
+                      <a:pPr algn="ctr"/>
+                      <a:r>
+                        <a:rPr sz="1000" b="1">
+                          <a:solidFill>
+                            <a:srgbClr val="FFFFFF"/>
+                          </a:solidFill>
+                          <a:latin typeface="Aptos"/>
+                        </a:rPr>
+                        <a:t>Reference</a:t>
+                      </a:r>
+                    </a:p>
+                  </a:txBody>
+                  <a:tcPr>
+                    <a:solidFill>
+                      <a:srgbClr val="3165A3"/>
+                    </a:solidFill>
+                  </a:tcPr>
+                </a:tc>
+              </a:tr>
+              <a:tr h="510540">
+                <a:tc>
+                  <a:txBody>
+                    <a:bodyPr/>
+                    <a:lstStyle/>
+                    <a:p>
+                      <a:pPr algn="ctr"/>
+                      <a:r>
+                        <a:rPr sz="1000">
+                          <a:solidFill>
+                            <a:srgbClr val="20252A"/>
+                          </a:solidFill>
+                          <a:latin typeface="Aptos"/>
+                        </a:rPr>
+                        <a:t>Conditional Flow Matching</a:t>
+                      </a:r>
+                    </a:p>
+                  </a:txBody>
+                  <a:tcPr>
+                    <a:solidFill>
+                      <a:srgbClr val="FFFFFF"/>
+                    </a:solidFill>
+                  </a:tcPr>
+                </a:tc>
+                <a:tc>
+                  <a:txBody>
+                    <a:bodyPr/>
+                    <a:lstStyle/>
+                    <a:p>
+                      <a:pPr algn="ctr"/>
+                      <a:r>
+                        <a:rPr sz="1000">
+                          <a:solidFill>
+                            <a:srgbClr val="20252A"/>
+                          </a:solidFill>
+                          <a:latin typeface="Aptos"/>
+                        </a:rPr>
+                        <a:t>Lipman et al., Flow Matching for Generative Modeling, ICLR 2023 / arXiv:2210.02747</a:t>
+                      </a:r>
+                    </a:p>
+                  </a:txBody>
+                  <a:tcPr>
+                    <a:solidFill>
+                      <a:srgbClr val="FFFFFF"/>
+                    </a:solidFill>
+                  </a:tcPr>
+                </a:tc>
+              </a:tr>
+              <a:tr h="510540">
+                <a:tc>
+                  <a:txBody>
+                    <a:bodyPr/>
+                    <a:lstStyle/>
+                    <a:p>
+                      <a:pPr algn="ctr"/>
+                      <a:r>
+                        <a:rPr sz="1000">
+                          <a:solidFill>
+                            <a:srgbClr val="20252A"/>
+                          </a:solidFill>
+                          <a:latin typeface="Aptos"/>
+                        </a:rPr>
+                        <a:t>UCE cell state</a:t>
+                      </a:r>
+                    </a:p>
+                  </a:txBody>
+                  <a:tcPr>
+                    <a:solidFill>
+                      <a:srgbClr val="F1F4F7"/>
+                    </a:solidFill>
+                  </a:tcPr>
+                </a:tc>
+                <a:tc>
+                  <a:txBody>
+                    <a:bodyPr/>
+                    <a:lstStyle/>
+                    <a:p>
+                      <a:pPr algn="ctr"/>
+                      <a:r>
+                        <a:rPr sz="1000">
+                          <a:solidFill>
+                            <a:srgbClr val="20252A"/>
+                          </a:solidFill>
+                          <a:latin typeface="Aptos"/>
+                        </a:rPr>
+                        <a:t>Rosen et al., Universal cell embeddings provide a foundation model for cell biology, Nature 2026</a:t>
+                      </a:r>
+                    </a:p>
+                  </a:txBody>
+                  <a:tcPr>
+                    <a:solidFill>
+                      <a:srgbClr val="F1F4F7"/>
+                    </a:solidFill>
+                  </a:tcPr>
+                </a:tc>
+              </a:tr>
+              <a:tr h="510540">
+                <a:tc>
+                  <a:txBody>
+                    <a:bodyPr/>
+                    <a:lstStyle/>
+                    <a:p>
+                      <a:pPr algn="ctr"/>
+                      <a:r>
+                        <a:rPr sz="1000">
+                          <a:solidFill>
+                            <a:srgbClr val="20252A"/>
+                          </a:solidFill>
+                          <a:latin typeface="Aptos"/>
+                        </a:rPr>
+                        <a:t>Sequence embeddings</a:t>
+                      </a:r>
+                    </a:p>
+                  </a:txBody>
+                  <a:tcPr>
+                    <a:solidFill>
+                      <a:srgbClr val="FFFFFF"/>
+                    </a:solidFill>
+                  </a:tcPr>
+                </a:tc>
+                <a:tc>
+                  <a:txBody>
+                    <a:bodyPr/>
+                    <a:lstStyle/>
+                    <a:p>
+                      <a:pPr algn="ctr"/>
+                      <a:r>
+                        <a:rPr sz="1000">
+                          <a:solidFill>
+                            <a:srgbClr val="20252A"/>
+                          </a:solidFill>
+                          <a:latin typeface="Aptos"/>
+                        </a:rPr>
+                        <a:t>Avsec et al., Advancing regulatory variant effect prediction with AlphaGenome, Nature, doi:10.1038/s41586-025-10014-0</a:t>
+                      </a:r>
+                    </a:p>
+                  </a:txBody>
+                  <a:tcPr>
+                    <a:solidFill>
+                      <a:srgbClr val="FFFFFF"/>
+                    </a:solidFill>
+                  </a:tcPr>
+                </a:tc>
+              </a:tr>
+              <a:tr h="510540">
+                <a:tc>
+                  <a:txBody>
+                    <a:bodyPr/>
+                    <a:lstStyle/>
+                    <a:p>
+                      <a:pPr algn="ctr"/>
+                      <a:r>
+                        <a:rPr sz="1000">
+                          <a:solidFill>
+                            <a:srgbClr val="20252A"/>
+                          </a:solidFill>
+                          <a:latin typeface="Aptos"/>
+                        </a:rPr>
+                        <a:t>ZSCAPE atlas</a:t>
+                      </a:r>
+                    </a:p>
+                  </a:txBody>
+                  <a:tcPr>
+                    <a:solidFill>
+                      <a:srgbClr val="F1F4F7"/>
+                    </a:solidFill>
+                  </a:tcPr>
+                </a:tc>
+                <a:tc>
+                  <a:txBody>
+                    <a:bodyPr/>
+                    <a:lstStyle/>
+                    <a:p>
+                      <a:pPr algn="ctr"/>
+                      <a:r>
+                        <a:rPr sz="1000">
+                          <a:solidFill>
+                            <a:srgbClr val="20252A"/>
+                          </a:solidFill>
+                          <a:latin typeface="Aptos"/>
+                        </a:rPr>
+                        <a:t>Saunders et al., Embryo-scale reverse genetics at single-cell resolution, Nature 2023</a:t>
+                      </a:r>
+                    </a:p>
+                  </a:txBody>
+                  <a:tcPr>
+                    <a:solidFill>
+                      <a:srgbClr val="F1F4F7"/>
+                    </a:solidFill>
+                  </a:tcPr>
+                </a:tc>
+              </a:tr>
+              <a:tr h="510540">
+                <a:tc>
+                  <a:txBody>
+                    <a:bodyPr/>
+                    <a:lstStyle/>
+                    <a:p>
+                      <a:pPr algn="ctr"/>
+                      <a:r>
+                        <a:rPr sz="1000">
+                          <a:solidFill>
+                            <a:srgbClr val="20252A"/>
+                          </a:solidFill>
+                          <a:latin typeface="Aptos"/>
+                        </a:rPr>
+                        <a:t>STREAM figures</a:t>
+                      </a:r>
+                    </a:p>
+                  </a:txBody>
+                  <a:tcPr>
+                    <a:solidFill>
+                      <a:srgbClr val="FFFFFF"/>
+                    </a:solidFill>
+                  </a:tcPr>
+                </a:tc>
+                <a:tc>
+                  <a:txBody>
+                    <a:bodyPr/>
+                    <a:lstStyle/>
+                    <a:p>
+                      <a:pPr algn="ctr"/>
+                      <a:r>
+                        <a:rPr sz="1000">
+                          <a:solidFill>
+                            <a:srgbClr val="20252A"/>
+                          </a:solidFill>
+                          <a:latin typeface="Aptos"/>
+                        </a:rPr>
+                        <a:t>Generated from project outputs: atlas UMAP, held-out CFM metrics, UCE ablations, and transfer evaluations</a:t>
+                      </a:r>
+                    </a:p>
+                  </a:txBody>
+                  <a:tcPr>
+                    <a:solidFill>
+                      <a:srgbClr val="FFFFFF"/>
+                    </a:solidFill>
+                  </a:tcPr>
+                </a:tc>
+              </a:tr>
+            </a:tbl>
+          </a:graphicData>
+        </a:graphic>
+      </p:graphicFrame>
+      <p:sp>
+        <p:nvSpPr>
+          <p:cNvPr id="4" name="Rounded Rectangle 3"/>
+          <p:cNvSpPr/>
+          <p:nvPr/>
+        </p:nvSpPr>
+        <p:spPr>
+          <a:xfrm>
+            <a:off x="1097280" y="4800600"/>
+            <a:ext cx="9966960" cy="777240"/>
+          </a:xfrm>
+          <a:prstGeom prst="roundRect">
+            <a:avLst/>
+          </a:prstGeom>
+          <a:solidFill>
+            <a:srgbClr val="E1EBF7"/>
+          </a:solidFill>
+          <a:ln w="13970">
+            <a:solidFill>
+              <a:srgbClr val="3165A3"/>
+            </a:solidFill>
+          </a:ln>
+        </p:spPr>
+        <p:style>
+          <a:lnRef idx="1">
+            <a:schemeClr val="accent1"/>
+          </a:lnRef>
+          <a:fillRef idx="3">
+            <a:schemeClr val="accent1"/>
+          </a:fillRef>
+          <a:effectRef idx="2">
+            <a:schemeClr val="accent1"/>
+          </a:effectRef>
+          <a:fontRef idx="minor">
+            <a:schemeClr val="lt1"/>
+          </a:fontRef>
+        </p:style>
+        <p:txBody>
+          <a:bodyPr rtlCol="0" anchor="ctr" lIns="73152" rIns="73152" tIns="54864" bIns="54864"/>
+          <a:lstStyle/>
+          <a:p>
+            <a:pPr algn="ctr"/>
+            <a:r>
+              <a:rPr sz="1300" b="1">
+                <a:solidFill>
+                  <a:srgbClr val="20252A"/>
+                </a:solidFill>
+                <a:latin typeface="Aptos"/>
+              </a:rPr>
+              <a:t>Displayed plots and diagrams are generated from this repository's analysis outputs or drawn schematically in the deck builder.</a:t>
+            </a:r>
+          </a:p>
+        </p:txBody>
+      </p:sp>
+      <p:sp>
+        <p:nvSpPr>
+          <p:cNvPr id="5" name="TextBox 4"/>
+          <p:cNvSpPr txBox="1"/>
+          <p:nvPr/>
+        </p:nvSpPr>
+        <p:spPr>
+          <a:xfrm>
+            <a:off x="1097280" y="5779008"/>
+            <a:ext cx="9966960" cy="320040"/>
+          </a:xfrm>
+          <a:prstGeom prst="rect">
+            <a:avLst/>
+          </a:prstGeom>
+          <a:noFill/>
+        </p:spPr>
+        <p:txBody>
+          <a:bodyPr wrap="none" lIns="36576" rIns="36576" tIns="18288" bIns="18288" anchor="t">
+            <a:spAutoFit/>
+          </a:bodyPr>
+          <a:lstStyle/>
+          <a:p>
+            <a:pPr algn="ctr"/>
+            <a:r>
+              <a:rPr sz="1200" b="0">
+                <a:solidFill>
+                  <a:srgbClr val="5C6773"/>
+                </a:solidFill>
+                <a:latin typeface="Aptos"/>
+              </a:rPr>
+              <a:t>The deck is reproducible from the slide builder script and current result CSV/PNG artifacts.</a:t>
             </a:r>
           </a:p>
         </p:txBody>
@@ -9740,14 +10913,68 @@
                 </a:solidFill>
                 <a:latin typeface="Aptos"/>
               </a:rPr>
-              <a:t>Mouse: 10k genes lowers full-panel loss; cross-attention is best by MSE</a:t>
+              <a:t>Learned vector fields can be visualized as velocity streams on the cell atlas</a:t>
+            </a:r>
+          </a:p>
+        </p:txBody>
+      </p:sp>
+      <p:sp>
+        <p:nvSpPr>
+          <p:cNvPr id="3" name="Rounded Rectangle 2"/>
+          <p:cNvSpPr/>
+          <p:nvPr/>
+        </p:nvSpPr>
+        <p:spPr>
+          <a:xfrm>
+            <a:off x="1161288" y="978408"/>
+            <a:ext cx="2468880" cy="384048"/>
+          </a:xfrm>
+          <a:prstGeom prst="roundRect">
+            <a:avLst/>
+          </a:prstGeom>
+          <a:solidFill>
+            <a:srgbClr val="E1EBF7"/>
+          </a:solidFill>
+          <a:ln w="13970">
+            <a:solidFill>
+              <a:srgbClr val="3165A3"/>
+            </a:solidFill>
+          </a:ln>
+        </p:spPr>
+        <p:style>
+          <a:lnRef idx="1">
+            <a:schemeClr val="accent1"/>
+          </a:lnRef>
+          <a:fillRef idx="3">
+            <a:schemeClr val="accent1"/>
+          </a:fillRef>
+          <a:effectRef idx="2">
+            <a:schemeClr val="accent1"/>
+          </a:effectRef>
+          <a:fontRef idx="minor">
+            <a:schemeClr val="lt1"/>
+          </a:fontRef>
+        </p:style>
+        <p:txBody>
+          <a:bodyPr rtlCol="0" anchor="ctr" lIns="73152" rIns="73152" tIns="54864" bIns="54864"/>
+          <a:lstStyle/>
+          <a:p>
+            <a:pPr algn="ctr"/>
+            <a:r>
+              <a:rPr sz="1200" b="1">
+                <a:solidFill>
+                  <a:srgbClr val="20252A"/>
+                </a:solidFill>
+                <a:latin typeface="Aptos"/>
+              </a:rPr>
+              <a:t>CFM</a:t>
             </a:r>
           </a:p>
         </p:txBody>
       </p:sp>
       <p:pic>
         <p:nvPicPr>
-          <p:cNvPr id="3" name="Picture 2" descr="mouse_full_panel.png"/>
+          <p:cNvPr id="4" name="Picture 3" descr="velocity_embedding_stream_standard_cfm.png"/>
           <p:cNvPicPr>
             <a:picLocks noChangeAspect="1"/>
           </p:cNvPicPr>
@@ -9761,8 +10988,8 @@
         </p:blipFill>
         <p:spPr>
           <a:xfrm>
-            <a:off x="685800" y="1211579"/>
-            <a:ext cx="7680960" cy="3840480"/>
+            <a:off x="502920" y="2192301"/>
+            <a:ext cx="3566160" cy="2555693"/>
           </a:xfrm>
           <a:prstGeom prst="rect">
             <a:avLst/>
@@ -9771,16 +10998,16 @@
       </p:pic>
       <p:sp>
         <p:nvSpPr>
-          <p:cNvPr id="4" name="Rectangle 3"/>
+          <p:cNvPr id="5" name="Rounded Rectangle 4"/>
           <p:cNvSpPr/>
           <p:nvPr/>
         </p:nvSpPr>
         <p:spPr>
           <a:xfrm>
-            <a:off x="8641080" y="1325880"/>
-            <a:ext cx="2194560" cy="914400"/>
-          </a:xfrm>
-          <a:prstGeom prst="rect">
+            <a:off x="5001768" y="978408"/>
+            <a:ext cx="2468880" cy="384048"/>
+          </a:xfrm>
+          <a:prstGeom prst="roundRect">
             <a:avLst/>
           </a:prstGeom>
           <a:solidFill>
@@ -9788,7 +11015,7 @@
           </a:solidFill>
           <a:ln w="13970">
             <a:solidFill>
-              <a:srgbClr val="D2D8DE"/>
+              <a:srgbClr val="539A5D"/>
             </a:solidFill>
           </a:ln>
         </p:spPr>
@@ -9812,142 +11039,61 @@
           <a:p>
             <a:pPr algn="ctr"/>
             <a:r>
-              <a:rPr sz="1300" b="0">
+              <a:rPr sz="1200" b="1">
                 <a:solidFill>
                   <a:srgbClr val="20252A"/>
                 </a:solidFill>
                 <a:latin typeface="Aptos"/>
               </a:rPr>
-              <a:t/>
-            </a:r>
-          </a:p>
-        </p:txBody>
-      </p:sp>
-      <p:sp>
-        <p:nvSpPr>
-          <p:cNvPr id="5" name="TextBox 4"/>
-          <p:cNvSpPr txBox="1"/>
-          <p:nvPr/>
-        </p:nvSpPr>
-        <p:spPr>
-          <a:xfrm>
-            <a:off x="8695944" y="1453895"/>
-            <a:ext cx="2084831" cy="329184"/>
+              <a:t>FiLM STREAM</a:t>
+            </a:r>
+          </a:p>
+        </p:txBody>
+      </p:sp>
+      <p:pic>
+        <p:nvPicPr>
+          <p:cNvPr id="6" name="Picture 5" descr="velocity_embedding_stream_film.png"/>
+          <p:cNvPicPr>
+            <a:picLocks noChangeAspect="1"/>
+          </p:cNvPicPr>
+          <p:nvPr/>
+        </p:nvPicPr>
+        <p:blipFill>
+          <a:blip r:embed="rId3"/>
+          <a:stretch>
+            <a:fillRect/>
+          </a:stretch>
+        </p:blipFill>
+        <p:spPr>
+          <a:xfrm>
+            <a:off x="4343400" y="2192301"/>
+            <a:ext cx="3566160" cy="2555693"/>
           </a:xfrm>
           <a:prstGeom prst="rect">
             <a:avLst/>
           </a:prstGeom>
-          <a:noFill/>
-        </p:spPr>
-        <p:txBody>
-          <a:bodyPr wrap="none" lIns="36576" rIns="36576" tIns="18288" bIns="18288" anchor="t">
-            <a:spAutoFit/>
-          </a:bodyPr>
-          <a:lstStyle/>
-          <a:p>
-            <a:pPr algn="ctr"/>
-            <a:r>
-              <a:rPr sz="2300" b="1">
-                <a:solidFill>
-                  <a:srgbClr val="20252A"/>
-                </a:solidFill>
-                <a:latin typeface="Aptos"/>
-              </a:rPr>
-              <a:t>20.28</a:t>
-            </a:r>
-          </a:p>
-        </p:txBody>
-      </p:sp>
-      <p:sp>
-        <p:nvSpPr>
-          <p:cNvPr id="6" name="TextBox 5"/>
-          <p:cNvSpPr txBox="1"/>
-          <p:nvPr/>
-        </p:nvSpPr>
-        <p:spPr>
-          <a:xfrm>
-            <a:off x="8714232" y="1856231"/>
-            <a:ext cx="2048255" cy="365760"/>
-          </a:xfrm>
-          <a:prstGeom prst="rect">
-            <a:avLst/>
-          </a:prstGeom>
-          <a:noFill/>
-        </p:spPr>
-        <p:txBody>
-          <a:bodyPr wrap="none" lIns="36576" rIns="36576" tIns="18288" bIns="18288" anchor="t">
-            <a:spAutoFit/>
-          </a:bodyPr>
-          <a:lstStyle/>
-          <a:p>
-            <a:pPr algn="ctr"/>
-            <a:r>
-              <a:rPr sz="1000" b="0">
-                <a:solidFill>
-                  <a:srgbClr val="5C6773"/>
-                </a:solidFill>
-                <a:latin typeface="Aptos"/>
-              </a:rPr>
-              <a:t>best 10k MSE</a:t>
-            </a:r>
-          </a:p>
-        </p:txBody>
-      </p:sp>
-      <p:sp>
-        <p:nvSpPr>
-          <p:cNvPr id="7" name="TextBox 6"/>
-          <p:cNvSpPr txBox="1"/>
-          <p:nvPr/>
-        </p:nvSpPr>
-        <p:spPr>
-          <a:xfrm>
-            <a:off x="8732520" y="2212848"/>
-            <a:ext cx="2011680" cy="256032"/>
-          </a:xfrm>
-          <a:prstGeom prst="rect">
-            <a:avLst/>
-          </a:prstGeom>
-          <a:noFill/>
-        </p:spPr>
-        <p:txBody>
-          <a:bodyPr wrap="none" lIns="36576" rIns="36576" tIns="18288" bIns="18288" anchor="t">
-            <a:spAutoFit/>
-          </a:bodyPr>
-          <a:lstStyle/>
-          <a:p>
-            <a:pPr algn="ctr"/>
-            <a:r>
-              <a:rPr sz="1300" b="1">
-                <a:solidFill>
-                  <a:srgbClr val="20252A"/>
-                </a:solidFill>
-                <a:latin typeface="Aptos"/>
-              </a:rPr>
-              <a:t>Cross-attn + UCE</a:t>
-            </a:r>
-          </a:p>
-        </p:txBody>
-      </p:sp>
-      <p:sp>
-        <p:nvSpPr>
-          <p:cNvPr id="8" name="Rectangle 7"/>
+        </p:spPr>
+      </p:pic>
+      <p:sp>
+        <p:nvSpPr>
+          <p:cNvPr id="7" name="Rounded Rectangle 6"/>
           <p:cNvSpPr/>
           <p:nvPr/>
         </p:nvSpPr>
         <p:spPr>
           <a:xfrm>
-            <a:off x="8641080" y="2788920"/>
-            <a:ext cx="2194560" cy="914400"/>
-          </a:xfrm>
-          <a:prstGeom prst="rect">
+            <a:off x="8842248" y="978408"/>
+            <a:ext cx="2468880" cy="384048"/>
+          </a:xfrm>
+          <a:prstGeom prst="roundRect">
             <a:avLst/>
           </a:prstGeom>
           <a:solidFill>
-            <a:srgbClr val="E1EBF7"/>
+            <a:srgbClr val="E0F1E5"/>
           </a:solidFill>
           <a:ln w="13970">
             <a:solidFill>
-              <a:srgbClr val="D2D8DE"/>
+              <a:srgbClr val="539A5D"/>
             </a:solidFill>
           </a:ln>
         </p:spPr>
@@ -9971,17 +11117,41 @@
           <a:p>
             <a:pPr algn="ctr"/>
             <a:r>
-              <a:rPr sz="1300" b="0">
+              <a:rPr sz="1200" b="1">
                 <a:solidFill>
                   <a:srgbClr val="20252A"/>
                 </a:solidFill>
                 <a:latin typeface="Aptos"/>
               </a:rPr>
-              <a:t/>
-            </a:r>
-          </a:p>
-        </p:txBody>
-      </p:sp>
+              <a:t>Cross-attn STREAM</a:t>
+            </a:r>
+          </a:p>
+        </p:txBody>
+      </p:sp>
+      <p:pic>
+        <p:nvPicPr>
+          <p:cNvPr id="8" name="Picture 7" descr="velocity_embedding_stream_cross_attention.png"/>
+          <p:cNvPicPr>
+            <a:picLocks noChangeAspect="1"/>
+          </p:cNvPicPr>
+          <p:nvPr/>
+        </p:nvPicPr>
+        <p:blipFill>
+          <a:blip r:embed="rId4"/>
+          <a:stretch>
+            <a:fillRect/>
+          </a:stretch>
+        </p:blipFill>
+        <p:spPr>
+          <a:xfrm>
+            <a:off x="8183880" y="2192301"/>
+            <a:ext cx="3566160" cy="2555693"/>
+          </a:xfrm>
+          <a:prstGeom prst="rect">
+            <a:avLst/>
+          </a:prstGeom>
+        </p:spPr>
+      </p:pic>
       <p:sp>
         <p:nvSpPr>
           <p:cNvPr id="9" name="TextBox 8"/>
@@ -9990,8 +11160,8 @@
         </p:nvSpPr>
         <p:spPr>
           <a:xfrm>
-            <a:off x="8695944" y="2916936"/>
-            <a:ext cx="2084831" cy="329184"/>
+            <a:off x="868680" y="5742432"/>
+            <a:ext cx="10515600" cy="320040"/>
           </a:xfrm>
           <a:prstGeom prst="rect">
             <a:avLst/>
@@ -10006,118 +11176,13 @@
           <a:p>
             <a:pPr algn="ctr"/>
             <a:r>
-              <a:rPr sz="2300" b="1">
-                <a:solidFill>
-                  <a:srgbClr val="20252A"/>
+              <a:rPr sz="1200" b="0">
+                <a:solidFill>
+                  <a:srgbClr val="5C6773"/>
                 </a:solidFill>
                 <a:latin typeface="Aptos"/>
               </a:rPr>
-              <a:t>1.594</a:t>
-            </a:r>
-          </a:p>
-        </p:txBody>
-      </p:sp>
-      <p:sp>
-        <p:nvSpPr>
-          <p:cNvPr id="10" name="TextBox 9"/>
-          <p:cNvSpPr txBox="1"/>
-          <p:nvPr/>
-        </p:nvSpPr>
-        <p:spPr>
-          <a:xfrm>
-            <a:off x="8714232" y="3319272"/>
-            <a:ext cx="2048255" cy="365760"/>
-          </a:xfrm>
-          <a:prstGeom prst="rect">
-            <a:avLst/>
-          </a:prstGeom>
-          <a:noFill/>
-        </p:spPr>
-        <p:txBody>
-          <a:bodyPr wrap="none" lIns="36576" rIns="36576" tIns="18288" bIns="18288" anchor="t">
-            <a:spAutoFit/>
-          </a:bodyPr>
-          <a:lstStyle/>
-          <a:p>
-            <a:pPr algn="ctr"/>
-            <a:r>
-              <a:rPr sz="1000" b="0">
-                <a:solidFill>
-                  <a:srgbClr val="5C6773"/>
-                </a:solidFill>
-                <a:latin typeface="Aptos"/>
-              </a:rPr>
-              <a:t>best 10k MAE</a:t>
-            </a:r>
-          </a:p>
-        </p:txBody>
-      </p:sp>
-      <p:sp>
-        <p:nvSpPr>
-          <p:cNvPr id="11" name="TextBox 10"/>
-          <p:cNvSpPr txBox="1"/>
-          <p:nvPr/>
-        </p:nvSpPr>
-        <p:spPr>
-          <a:xfrm>
-            <a:off x="8732520" y="3675887"/>
-            <a:ext cx="2011680" cy="256032"/>
-          </a:xfrm>
-          <a:prstGeom prst="rect">
-            <a:avLst/>
-          </a:prstGeom>
-          <a:noFill/>
-        </p:spPr>
-        <p:txBody>
-          <a:bodyPr wrap="none" lIns="36576" rIns="36576" tIns="18288" bIns="18288" anchor="t">
-            <a:spAutoFit/>
-          </a:bodyPr>
-          <a:lstStyle/>
-          <a:p>
-            <a:pPr algn="ctr"/>
-            <a:r>
-              <a:rPr sz="1300" b="1">
-                <a:solidFill>
-                  <a:srgbClr val="20252A"/>
-                </a:solidFill>
-                <a:latin typeface="Aptos"/>
-              </a:rPr>
-              <a:t>Cross-attn + UCE</a:t>
-            </a:r>
-          </a:p>
-        </p:txBody>
-      </p:sp>
-      <p:sp>
-        <p:nvSpPr>
-          <p:cNvPr id="12" name="TextBox 11"/>
-          <p:cNvSpPr txBox="1"/>
-          <p:nvPr/>
-        </p:nvSpPr>
-        <p:spPr>
-          <a:xfrm>
-            <a:off x="822960" y="5715000"/>
-            <a:ext cx="10241280" cy="365760"/>
-          </a:xfrm>
-          <a:prstGeom prst="rect">
-            <a:avLst/>
-          </a:prstGeom>
-          <a:noFill/>
-        </p:spPr>
-        <p:txBody>
-          <a:bodyPr wrap="none" lIns="36576" rIns="36576" tIns="18288" bIns="18288" anchor="t">
-            <a:spAutoFit/>
-          </a:bodyPr>
-          <a:lstStyle/>
-          <a:p>
-            <a:pPr algn="ctr"/>
-            <a:r>
-              <a:rPr sz="1200" b="0">
-                <a:solidFill>
-                  <a:srgbClr val="5C6773"/>
-                </a:solidFill>
-                <a:latin typeface="Aptos"/>
-              </a:rPr>
-              <a:t>Full-panel losses compare each model on its own selected genes; the legacy-panel slide controls for output genes.</a:t>
+              <a:t>Illustrative stream plots show how model-predicted velocities align with the atlas manifold.</a:t>
             </a:r>
           </a:p>
         </p:txBody>
@@ -10178,14 +11243,14 @@
                 </a:solidFill>
                 <a:latin typeface="Aptos"/>
               </a:rPr>
-              <a:t>Fair legacy-panel scoring shows the 10k cross-attention gain is real</a:t>
+              <a:t>Mouse: 10k genes lowers full-panel loss; cross-attention is best by MSE</a:t>
             </a:r>
           </a:p>
         </p:txBody>
       </p:sp>
       <p:pic>
         <p:nvPicPr>
-          <p:cNvPr id="3" name="Picture 2" descr="legacy_heatmap.png"/>
+          <p:cNvPr id="3" name="Picture 2" descr="mouse_full_panel.png"/>
           <p:cNvPicPr>
             <a:picLocks noChangeAspect="1"/>
           </p:cNvPicPr>
@@ -10199,8 +11264,8 @@
         </p:blipFill>
         <p:spPr>
           <a:xfrm>
-            <a:off x="777240" y="1234439"/>
-            <a:ext cx="7680960" cy="3200400"/>
+            <a:off x="685800" y="1211579"/>
+            <a:ext cx="7680960" cy="3840480"/>
           </a:xfrm>
           <a:prstGeom prst="rect">
             <a:avLst/>
@@ -10209,24 +11274,24 @@
       </p:pic>
       <p:sp>
         <p:nvSpPr>
-          <p:cNvPr id="4" name="Rounded Rectangle 3"/>
+          <p:cNvPr id="4" name="Rectangle 3"/>
           <p:cNvSpPr/>
           <p:nvPr/>
         </p:nvSpPr>
         <p:spPr>
           <a:xfrm>
-            <a:off x="8823960" y="1371600"/>
-            <a:ext cx="2331720" cy="777240"/>
-          </a:xfrm>
-          <a:prstGeom prst="roundRect">
+            <a:off x="8641080" y="1325880"/>
+            <a:ext cx="2194560" cy="914400"/>
+          </a:xfrm>
+          <a:prstGeom prst="rect">
             <a:avLst/>
           </a:prstGeom>
           <a:solidFill>
-            <a:srgbClr val="F9E0DC"/>
+            <a:srgbClr val="E0F1E5"/>
           </a:solidFill>
           <a:ln w="13970">
             <a:solidFill>
-              <a:srgbClr val="BE4B49"/>
+              <a:srgbClr val="D2D8DE"/>
             </a:solidFill>
           </a:ln>
         </p:spPr>
@@ -10250,37 +11315,142 @@
           <a:p>
             <a:pPr algn="ctr"/>
             <a:r>
-              <a:rPr sz="1300" b="1">
+              <a:rPr sz="1300" b="0">
                 <a:solidFill>
                   <a:srgbClr val="20252A"/>
                 </a:solidFill>
                 <a:latin typeface="Aptos"/>
               </a:rPr>
-              <a:t>5k models do not improve the 1,984-gene metric</a:t>
-            </a:r>
-          </a:p>
-        </p:txBody>
-      </p:sp>
-      <p:sp>
-        <p:nvSpPr>
-          <p:cNvPr id="5" name="Rounded Rectangle 4"/>
+              <a:t/>
+            </a:r>
+          </a:p>
+        </p:txBody>
+      </p:sp>
+      <p:sp>
+        <p:nvSpPr>
+          <p:cNvPr id="5" name="TextBox 4"/>
+          <p:cNvSpPr txBox="1"/>
+          <p:nvPr/>
+        </p:nvSpPr>
+        <p:spPr>
+          <a:xfrm>
+            <a:off x="8695944" y="1453895"/>
+            <a:ext cx="2084831" cy="329184"/>
+          </a:xfrm>
+          <a:prstGeom prst="rect">
+            <a:avLst/>
+          </a:prstGeom>
+          <a:noFill/>
+        </p:spPr>
+        <p:txBody>
+          <a:bodyPr wrap="none" lIns="36576" rIns="36576" tIns="18288" bIns="18288" anchor="t">
+            <a:spAutoFit/>
+          </a:bodyPr>
+          <a:lstStyle/>
+          <a:p>
+            <a:pPr algn="ctr"/>
+            <a:r>
+              <a:rPr sz="2300" b="1">
+                <a:solidFill>
+                  <a:srgbClr val="20252A"/>
+                </a:solidFill>
+                <a:latin typeface="Aptos"/>
+              </a:rPr>
+              <a:t>20.28</a:t>
+            </a:r>
+          </a:p>
+        </p:txBody>
+      </p:sp>
+      <p:sp>
+        <p:nvSpPr>
+          <p:cNvPr id="6" name="TextBox 5"/>
+          <p:cNvSpPr txBox="1"/>
+          <p:nvPr/>
+        </p:nvSpPr>
+        <p:spPr>
+          <a:xfrm>
+            <a:off x="8714232" y="1856231"/>
+            <a:ext cx="2048255" cy="365760"/>
+          </a:xfrm>
+          <a:prstGeom prst="rect">
+            <a:avLst/>
+          </a:prstGeom>
+          <a:noFill/>
+        </p:spPr>
+        <p:txBody>
+          <a:bodyPr wrap="none" lIns="36576" rIns="36576" tIns="18288" bIns="18288" anchor="t">
+            <a:spAutoFit/>
+          </a:bodyPr>
+          <a:lstStyle/>
+          <a:p>
+            <a:pPr algn="ctr"/>
+            <a:r>
+              <a:rPr sz="1000" b="0">
+                <a:solidFill>
+                  <a:srgbClr val="5C6773"/>
+                </a:solidFill>
+                <a:latin typeface="Aptos"/>
+              </a:rPr>
+              <a:t>best 10k MSE</a:t>
+            </a:r>
+          </a:p>
+        </p:txBody>
+      </p:sp>
+      <p:sp>
+        <p:nvSpPr>
+          <p:cNvPr id="7" name="TextBox 6"/>
+          <p:cNvSpPr txBox="1"/>
+          <p:nvPr/>
+        </p:nvSpPr>
+        <p:spPr>
+          <a:xfrm>
+            <a:off x="8732520" y="2212848"/>
+            <a:ext cx="2011680" cy="256032"/>
+          </a:xfrm>
+          <a:prstGeom prst="rect">
+            <a:avLst/>
+          </a:prstGeom>
+          <a:noFill/>
+        </p:spPr>
+        <p:txBody>
+          <a:bodyPr wrap="none" lIns="36576" rIns="36576" tIns="18288" bIns="18288" anchor="t">
+            <a:spAutoFit/>
+          </a:bodyPr>
+          <a:lstStyle/>
+          <a:p>
+            <a:pPr algn="ctr"/>
+            <a:r>
+              <a:rPr sz="1300" b="1">
+                <a:solidFill>
+                  <a:srgbClr val="20252A"/>
+                </a:solidFill>
+                <a:latin typeface="Aptos"/>
+              </a:rPr>
+              <a:t>Cross-attn + UCE</a:t>
+            </a:r>
+          </a:p>
+        </p:txBody>
+      </p:sp>
+      <p:sp>
+        <p:nvSpPr>
+          <p:cNvPr id="8" name="Rectangle 7"/>
           <p:cNvSpPr/>
           <p:nvPr/>
         </p:nvSpPr>
         <p:spPr>
           <a:xfrm>
-            <a:off x="8823960" y="2514600"/>
-            <a:ext cx="2331720" cy="868680"/>
-          </a:xfrm>
-          <a:prstGeom prst="roundRect">
+            <a:off x="8641080" y="2788920"/>
+            <a:ext cx="2194560" cy="914400"/>
+          </a:xfrm>
+          <a:prstGeom prst="rect">
             <a:avLst/>
           </a:prstGeom>
           <a:solidFill>
-            <a:srgbClr val="E0F1E5"/>
+            <a:srgbClr val="E1EBF7"/>
           </a:solidFill>
           <a:ln w="13970">
             <a:solidFill>
-              <a:srgbClr val="539A5D"/>
+              <a:srgbClr val="D2D8DE"/>
             </a:solidFill>
           </a:ln>
         </p:spPr>
@@ -10304,81 +11474,27 @@
           <a:p>
             <a:pPr algn="ctr"/>
             <a:r>
-              <a:rPr sz="1300" b="1">
+              <a:rPr sz="1300" b="0">
                 <a:solidFill>
                   <a:srgbClr val="20252A"/>
                 </a:solidFill>
                 <a:latin typeface="Aptos"/>
               </a:rPr>
-              <a:t>10k cross-attention improves loss from 84.8 to 80.5</a:t>
-            </a:r>
-          </a:p>
-        </p:txBody>
-      </p:sp>
-      <p:sp>
-        <p:nvSpPr>
-          <p:cNvPr id="6" name="Rounded Rectangle 5"/>
-          <p:cNvSpPr/>
-          <p:nvPr/>
-        </p:nvSpPr>
-        <p:spPr>
-          <a:xfrm>
-            <a:off x="8823960" y="3840480"/>
-            <a:ext cx="2331720" cy="868680"/>
-          </a:xfrm>
-          <a:prstGeom prst="roundRect">
-            <a:avLst/>
-          </a:prstGeom>
-          <a:solidFill>
-            <a:srgbClr val="E0F1E5"/>
-          </a:solidFill>
-          <a:ln w="13970">
-            <a:solidFill>
-              <a:srgbClr val="539A5D"/>
-            </a:solidFill>
-          </a:ln>
-        </p:spPr>
-        <p:style>
-          <a:lnRef idx="1">
-            <a:schemeClr val="accent1"/>
-          </a:lnRef>
-          <a:fillRef idx="3">
-            <a:schemeClr val="accent1"/>
-          </a:fillRef>
-          <a:effectRef idx="2">
-            <a:schemeClr val="accent1"/>
-          </a:effectRef>
-          <a:fontRef idx="minor">
-            <a:schemeClr val="lt1"/>
-          </a:fontRef>
-        </p:style>
-        <p:txBody>
-          <a:bodyPr rtlCol="0" anchor="ctr" lIns="73152" rIns="73152" tIns="54864" bIns="54864"/>
-          <a:lstStyle/>
-          <a:p>
-            <a:pPr algn="ctr"/>
-            <a:r>
-              <a:rPr sz="1300" b="1">
-                <a:solidFill>
-                  <a:srgbClr val="20252A"/>
-                </a:solidFill>
-                <a:latin typeface="Aptos"/>
-              </a:rPr>
-              <a:t>10k UCE cross-attention improves further to 78.7</a:t>
-            </a:r>
-          </a:p>
-        </p:txBody>
-      </p:sp>
-      <p:sp>
-        <p:nvSpPr>
-          <p:cNvPr id="7" name="TextBox 6"/>
+              <a:t/>
+            </a:r>
+          </a:p>
+        </p:txBody>
+      </p:sp>
+      <p:sp>
+        <p:nvSpPr>
+          <p:cNvPr id="9" name="TextBox 8"/>
           <p:cNvSpPr txBox="1"/>
           <p:nvPr/>
         </p:nvSpPr>
         <p:spPr>
           <a:xfrm>
-            <a:off x="914400" y="5486400"/>
-            <a:ext cx="10058400" cy="365760"/>
+            <a:off x="8695944" y="2916936"/>
+            <a:ext cx="2084831" cy="329184"/>
           </a:xfrm>
           <a:prstGeom prst="rect">
             <a:avLst/>
@@ -10393,13 +11509,118 @@
           <a:p>
             <a:pPr algn="ctr"/>
             <a:r>
-              <a:rPr sz="1300" b="0">
-                <a:solidFill>
-                  <a:srgbClr val="5C6773"/>
+              <a:rPr sz="2300" b="1">
+                <a:solidFill>
+                  <a:srgbClr val="20252A"/>
                 </a:solidFill>
                 <a:latin typeface="Aptos"/>
               </a:rPr>
-              <a:t>Numbers are held-out MSE on the same original gene panel; lower is better.</a:t>
+              <a:t>1.594</a:t>
+            </a:r>
+          </a:p>
+        </p:txBody>
+      </p:sp>
+      <p:sp>
+        <p:nvSpPr>
+          <p:cNvPr id="10" name="TextBox 9"/>
+          <p:cNvSpPr txBox="1"/>
+          <p:nvPr/>
+        </p:nvSpPr>
+        <p:spPr>
+          <a:xfrm>
+            <a:off x="8714232" y="3319272"/>
+            <a:ext cx="2048255" cy="365760"/>
+          </a:xfrm>
+          <a:prstGeom prst="rect">
+            <a:avLst/>
+          </a:prstGeom>
+          <a:noFill/>
+        </p:spPr>
+        <p:txBody>
+          <a:bodyPr wrap="none" lIns="36576" rIns="36576" tIns="18288" bIns="18288" anchor="t">
+            <a:spAutoFit/>
+          </a:bodyPr>
+          <a:lstStyle/>
+          <a:p>
+            <a:pPr algn="ctr"/>
+            <a:r>
+              <a:rPr sz="1000" b="0">
+                <a:solidFill>
+                  <a:srgbClr val="5C6773"/>
+                </a:solidFill>
+                <a:latin typeface="Aptos"/>
+              </a:rPr>
+              <a:t>best 10k MAE</a:t>
+            </a:r>
+          </a:p>
+        </p:txBody>
+      </p:sp>
+      <p:sp>
+        <p:nvSpPr>
+          <p:cNvPr id="11" name="TextBox 10"/>
+          <p:cNvSpPr txBox="1"/>
+          <p:nvPr/>
+        </p:nvSpPr>
+        <p:spPr>
+          <a:xfrm>
+            <a:off x="8732520" y="3675887"/>
+            <a:ext cx="2011680" cy="256032"/>
+          </a:xfrm>
+          <a:prstGeom prst="rect">
+            <a:avLst/>
+          </a:prstGeom>
+          <a:noFill/>
+        </p:spPr>
+        <p:txBody>
+          <a:bodyPr wrap="none" lIns="36576" rIns="36576" tIns="18288" bIns="18288" anchor="t">
+            <a:spAutoFit/>
+          </a:bodyPr>
+          <a:lstStyle/>
+          <a:p>
+            <a:pPr algn="ctr"/>
+            <a:r>
+              <a:rPr sz="1300" b="1">
+                <a:solidFill>
+                  <a:srgbClr val="20252A"/>
+                </a:solidFill>
+                <a:latin typeface="Aptos"/>
+              </a:rPr>
+              <a:t>Cross-attn + UCE</a:t>
+            </a:r>
+          </a:p>
+        </p:txBody>
+      </p:sp>
+      <p:sp>
+        <p:nvSpPr>
+          <p:cNvPr id="12" name="TextBox 11"/>
+          <p:cNvSpPr txBox="1"/>
+          <p:nvPr/>
+        </p:nvSpPr>
+        <p:spPr>
+          <a:xfrm>
+            <a:off x="822960" y="5715000"/>
+            <a:ext cx="10241280" cy="365760"/>
+          </a:xfrm>
+          <a:prstGeom prst="rect">
+            <a:avLst/>
+          </a:prstGeom>
+          <a:noFill/>
+        </p:spPr>
+        <p:txBody>
+          <a:bodyPr wrap="none" lIns="36576" rIns="36576" tIns="18288" bIns="18288" anchor="t">
+            <a:spAutoFit/>
+          </a:bodyPr>
+          <a:lstStyle/>
+          <a:p>
+            <a:pPr algn="ctr"/>
+            <a:r>
+              <a:rPr sz="1200" b="0">
+                <a:solidFill>
+                  <a:srgbClr val="5C6773"/>
+                </a:solidFill>
+                <a:latin typeface="Aptos"/>
+              </a:rPr>
+              <a:t>Full-panel losses compare each model on its own selected genes; the legacy-panel slide controls for output genes.</a:t>
             </a:r>
           </a:p>
         </p:txBody>
@@ -10413,6 +11634,288 @@
 </file>
 
 <file path=ppt/slides/slide8.xml><?xml version="1.0" encoding="utf-8"?>
+<p:sld xmlns:a="http://schemas.openxmlformats.org/drawingml/2006/main" xmlns:p="http://schemas.openxmlformats.org/presentationml/2006/main" xmlns:r="http://schemas.openxmlformats.org/officeDocument/2006/relationships">
+  <p:cSld>
+    <p:bg>
+      <p:bgPr>
+        <a:solidFill>
+          <a:srgbClr val="F8F9FA"/>
+        </a:solidFill>
+        <a:effectLst/>
+      </p:bgPr>
+    </p:bg>
+    <p:spTree>
+      <p:nvGrpSpPr>
+        <p:cNvPr id="1" name=""/>
+        <p:cNvGrpSpPr/>
+        <p:nvPr/>
+      </p:nvGrpSpPr>
+      <p:grpSpPr/>
+      <p:sp>
+        <p:nvSpPr>
+          <p:cNvPr id="2" name="TextBox 1"/>
+          <p:cNvSpPr txBox="1"/>
+          <p:nvPr/>
+        </p:nvSpPr>
+        <p:spPr>
+          <a:xfrm>
+            <a:off x="502920" y="237744"/>
+            <a:ext cx="11155680" cy="438912"/>
+          </a:xfrm>
+          <a:prstGeom prst="rect">
+            <a:avLst/>
+          </a:prstGeom>
+          <a:noFill/>
+        </p:spPr>
+        <p:txBody>
+          <a:bodyPr wrap="none" lIns="36576" rIns="36576" tIns="18288" bIns="18288" anchor="t">
+            <a:spAutoFit/>
+          </a:bodyPr>
+          <a:lstStyle/>
+          <a:p>
+            <a:pPr algn="l"/>
+            <a:r>
+              <a:rPr sz="2500" b="1">
+                <a:solidFill>
+                  <a:srgbClr val="20252A"/>
+                </a:solidFill>
+                <a:latin typeface="Aptos"/>
+              </a:rPr>
+              <a:t>Fair legacy-panel scoring shows the 10k cross-attention gain is real</a:t>
+            </a:r>
+          </a:p>
+        </p:txBody>
+      </p:sp>
+      <p:pic>
+        <p:nvPicPr>
+          <p:cNvPr id="3" name="Picture 2" descr="legacy_heatmap.png"/>
+          <p:cNvPicPr>
+            <a:picLocks noChangeAspect="1"/>
+          </p:cNvPicPr>
+          <p:nvPr/>
+        </p:nvPicPr>
+        <p:blipFill>
+          <a:blip r:embed="rId2"/>
+          <a:stretch>
+            <a:fillRect/>
+          </a:stretch>
+        </p:blipFill>
+        <p:spPr>
+          <a:xfrm>
+            <a:off x="777240" y="1234439"/>
+            <a:ext cx="7680960" cy="3200400"/>
+          </a:xfrm>
+          <a:prstGeom prst="rect">
+            <a:avLst/>
+          </a:prstGeom>
+        </p:spPr>
+      </p:pic>
+      <p:sp>
+        <p:nvSpPr>
+          <p:cNvPr id="4" name="Rounded Rectangle 3"/>
+          <p:cNvSpPr/>
+          <p:nvPr/>
+        </p:nvSpPr>
+        <p:spPr>
+          <a:xfrm>
+            <a:off x="8823960" y="1371600"/>
+            <a:ext cx="2331720" cy="777240"/>
+          </a:xfrm>
+          <a:prstGeom prst="roundRect">
+            <a:avLst/>
+          </a:prstGeom>
+          <a:solidFill>
+            <a:srgbClr val="F9E0DC"/>
+          </a:solidFill>
+          <a:ln w="13970">
+            <a:solidFill>
+              <a:srgbClr val="BE4B49"/>
+            </a:solidFill>
+          </a:ln>
+        </p:spPr>
+        <p:style>
+          <a:lnRef idx="1">
+            <a:schemeClr val="accent1"/>
+          </a:lnRef>
+          <a:fillRef idx="3">
+            <a:schemeClr val="accent1"/>
+          </a:fillRef>
+          <a:effectRef idx="2">
+            <a:schemeClr val="accent1"/>
+          </a:effectRef>
+          <a:fontRef idx="minor">
+            <a:schemeClr val="lt1"/>
+          </a:fontRef>
+        </p:style>
+        <p:txBody>
+          <a:bodyPr rtlCol="0" anchor="ctr" lIns="73152" rIns="73152" tIns="54864" bIns="54864"/>
+          <a:lstStyle/>
+          <a:p>
+            <a:pPr algn="ctr"/>
+            <a:r>
+              <a:rPr sz="1300" b="1">
+                <a:solidFill>
+                  <a:srgbClr val="20252A"/>
+                </a:solidFill>
+                <a:latin typeface="Aptos"/>
+              </a:rPr>
+              <a:t>5k models do not improve the 1,984-gene metric</a:t>
+            </a:r>
+          </a:p>
+        </p:txBody>
+      </p:sp>
+      <p:sp>
+        <p:nvSpPr>
+          <p:cNvPr id="5" name="Rounded Rectangle 4"/>
+          <p:cNvSpPr/>
+          <p:nvPr/>
+        </p:nvSpPr>
+        <p:spPr>
+          <a:xfrm>
+            <a:off x="8823960" y="2514600"/>
+            <a:ext cx="2331720" cy="868680"/>
+          </a:xfrm>
+          <a:prstGeom prst="roundRect">
+            <a:avLst/>
+          </a:prstGeom>
+          <a:solidFill>
+            <a:srgbClr val="E0F1E5"/>
+          </a:solidFill>
+          <a:ln w="13970">
+            <a:solidFill>
+              <a:srgbClr val="539A5D"/>
+            </a:solidFill>
+          </a:ln>
+        </p:spPr>
+        <p:style>
+          <a:lnRef idx="1">
+            <a:schemeClr val="accent1"/>
+          </a:lnRef>
+          <a:fillRef idx="3">
+            <a:schemeClr val="accent1"/>
+          </a:fillRef>
+          <a:effectRef idx="2">
+            <a:schemeClr val="accent1"/>
+          </a:effectRef>
+          <a:fontRef idx="minor">
+            <a:schemeClr val="lt1"/>
+          </a:fontRef>
+        </p:style>
+        <p:txBody>
+          <a:bodyPr rtlCol="0" anchor="ctr" lIns="73152" rIns="73152" tIns="54864" bIns="54864"/>
+          <a:lstStyle/>
+          <a:p>
+            <a:pPr algn="ctr"/>
+            <a:r>
+              <a:rPr sz="1300" b="1">
+                <a:solidFill>
+                  <a:srgbClr val="20252A"/>
+                </a:solidFill>
+                <a:latin typeface="Aptos"/>
+              </a:rPr>
+              <a:t>10k cross-attention improves loss from 84.8 to 80.5</a:t>
+            </a:r>
+          </a:p>
+        </p:txBody>
+      </p:sp>
+      <p:sp>
+        <p:nvSpPr>
+          <p:cNvPr id="6" name="Rounded Rectangle 5"/>
+          <p:cNvSpPr/>
+          <p:nvPr/>
+        </p:nvSpPr>
+        <p:spPr>
+          <a:xfrm>
+            <a:off x="8823960" y="3840480"/>
+            <a:ext cx="2331720" cy="868680"/>
+          </a:xfrm>
+          <a:prstGeom prst="roundRect">
+            <a:avLst/>
+          </a:prstGeom>
+          <a:solidFill>
+            <a:srgbClr val="E0F1E5"/>
+          </a:solidFill>
+          <a:ln w="13970">
+            <a:solidFill>
+              <a:srgbClr val="539A5D"/>
+            </a:solidFill>
+          </a:ln>
+        </p:spPr>
+        <p:style>
+          <a:lnRef idx="1">
+            <a:schemeClr val="accent1"/>
+          </a:lnRef>
+          <a:fillRef idx="3">
+            <a:schemeClr val="accent1"/>
+          </a:fillRef>
+          <a:effectRef idx="2">
+            <a:schemeClr val="accent1"/>
+          </a:effectRef>
+          <a:fontRef idx="minor">
+            <a:schemeClr val="lt1"/>
+          </a:fontRef>
+        </p:style>
+        <p:txBody>
+          <a:bodyPr rtlCol="0" anchor="ctr" lIns="73152" rIns="73152" tIns="54864" bIns="54864"/>
+          <a:lstStyle/>
+          <a:p>
+            <a:pPr algn="ctr"/>
+            <a:r>
+              <a:rPr sz="1300" b="1">
+                <a:solidFill>
+                  <a:srgbClr val="20252A"/>
+                </a:solidFill>
+                <a:latin typeface="Aptos"/>
+              </a:rPr>
+              <a:t>10k UCE cross-attention improves further to 78.7</a:t>
+            </a:r>
+          </a:p>
+        </p:txBody>
+      </p:sp>
+      <p:sp>
+        <p:nvSpPr>
+          <p:cNvPr id="7" name="TextBox 6"/>
+          <p:cNvSpPr txBox="1"/>
+          <p:nvPr/>
+        </p:nvSpPr>
+        <p:spPr>
+          <a:xfrm>
+            <a:off x="914400" y="5486400"/>
+            <a:ext cx="10058400" cy="365760"/>
+          </a:xfrm>
+          <a:prstGeom prst="rect">
+            <a:avLst/>
+          </a:prstGeom>
+          <a:noFill/>
+        </p:spPr>
+        <p:txBody>
+          <a:bodyPr wrap="none" lIns="36576" rIns="36576" tIns="18288" bIns="18288" anchor="t">
+            <a:spAutoFit/>
+          </a:bodyPr>
+          <a:lstStyle/>
+          <a:p>
+            <a:pPr algn="ctr"/>
+            <a:r>
+              <a:rPr sz="1300" b="0">
+                <a:solidFill>
+                  <a:srgbClr val="5C6773"/>
+                </a:solidFill>
+                <a:latin typeface="Aptos"/>
+              </a:rPr>
+              <a:t>Numbers are held-out MSE on the same original gene panel; lower is better.</a:t>
+            </a:r>
+          </a:p>
+        </p:txBody>
+      </p:sp>
+    </p:spTree>
+  </p:cSld>
+  <p:clrMapOvr>
+    <a:masterClrMapping/>
+  </p:clrMapOvr>
+</p:sld>
+</file>
+
+<file path=ppt/slides/slide9.xml><?xml version="1.0" encoding="utf-8"?>
 <p:sld xmlns:a="http://schemas.openxmlformats.org/drawingml/2006/main" xmlns:p="http://schemas.openxmlformats.org/presentationml/2006/main" xmlns:r="http://schemas.openxmlformats.org/officeDocument/2006/relationships">
   <p:cSld>
     <p:bg>
@@ -11265,713 +12768,6 @@
 </p:sld>
 </file>
 
-<file path=ppt/slides/slide9.xml><?xml version="1.0" encoding="utf-8"?>
-<p:sld xmlns:a="http://schemas.openxmlformats.org/drawingml/2006/main" xmlns:p="http://schemas.openxmlformats.org/presentationml/2006/main" xmlns:r="http://schemas.openxmlformats.org/officeDocument/2006/relationships">
-  <p:cSld>
-    <p:bg>
-      <p:bgPr>
-        <a:solidFill>
-          <a:srgbClr val="F8F9FA"/>
-        </a:solidFill>
-        <a:effectLst/>
-      </p:bgPr>
-    </p:bg>
-    <p:spTree>
-      <p:nvGrpSpPr>
-        <p:cNvPr id="1" name=""/>
-        <p:cNvGrpSpPr/>
-        <p:nvPr/>
-      </p:nvGrpSpPr>
-      <p:grpSpPr/>
-      <p:sp>
-        <p:nvSpPr>
-          <p:cNvPr id="2" name="TextBox 1"/>
-          <p:cNvSpPr txBox="1"/>
-          <p:nvPr/>
-        </p:nvSpPr>
-        <p:spPr>
-          <a:xfrm>
-            <a:off x="502920" y="237744"/>
-            <a:ext cx="11155680" cy="438912"/>
-          </a:xfrm>
-          <a:prstGeom prst="rect">
-            <a:avLst/>
-          </a:prstGeom>
-          <a:noFill/>
-        </p:spPr>
-        <p:txBody>
-          <a:bodyPr wrap="none" lIns="36576" rIns="36576" tIns="18288" bIns="18288" anchor="t">
-            <a:spAutoFit/>
-          </a:bodyPr>
-          <a:lstStyle/>
-          <a:p>
-            <a:pPr algn="l"/>
-            <a:r>
-              <a:rPr sz="2500" b="1">
-                <a:solidFill>
-                  <a:srgbClr val="20252A"/>
-                </a:solidFill>
-                <a:latin typeface="Aptos"/>
-              </a:rPr>
-              <a:t>Cross-species transfer swaps the genome and cell-state vocabulary, not the training objective</a:t>
-            </a:r>
-          </a:p>
-        </p:txBody>
-      </p:sp>
-      <p:sp>
-        <p:nvSpPr>
-          <p:cNvPr id="3" name="Rounded Rectangle 2"/>
-          <p:cNvSpPr/>
-          <p:nvPr/>
-        </p:nvSpPr>
-        <p:spPr>
-          <a:xfrm>
-            <a:off x="777240" y="1325880"/>
-            <a:ext cx="2011680" cy="868680"/>
-          </a:xfrm>
-          <a:prstGeom prst="roundRect">
-            <a:avLst/>
-          </a:prstGeom>
-          <a:solidFill>
-            <a:srgbClr val="E1EBF7"/>
-          </a:solidFill>
-          <a:ln w="13970">
-            <a:solidFill>
-              <a:srgbClr val="3165A3"/>
-            </a:solidFill>
-          </a:ln>
-        </p:spPr>
-        <p:style>
-          <a:lnRef idx="1">
-            <a:schemeClr val="accent1"/>
-          </a:lnRef>
-          <a:fillRef idx="3">
-            <a:schemeClr val="accent1"/>
-          </a:fillRef>
-          <a:effectRef idx="2">
-            <a:schemeClr val="accent1"/>
-          </a:effectRef>
-          <a:fontRef idx="minor">
-            <a:schemeClr val="lt1"/>
-          </a:fontRef>
-        </p:style>
-        <p:txBody>
-          <a:bodyPr rtlCol="0" anchor="ctr" lIns="73152" rIns="73152" tIns="54864" bIns="54864"/>
-          <a:lstStyle/>
-          <a:p>
-            <a:pPr algn="ctr"/>
-            <a:r>
-              <a:rPr sz="1300" b="1">
-                <a:solidFill>
-                  <a:srgbClr val="20252A"/>
-                </a:solidFill>
-                <a:latin typeface="Aptos"/>
-              </a:rPr>
-              <a:t>mouse 10k
-UCE cross-attn</a:t>
-            </a:r>
-          </a:p>
-        </p:txBody>
-      </p:sp>
-      <p:sp>
-        <p:nvSpPr>
-          <p:cNvPr id="4" name="Rounded Rectangle 3"/>
-          <p:cNvSpPr/>
-          <p:nvPr/>
-        </p:nvSpPr>
-        <p:spPr>
-          <a:xfrm>
-            <a:off x="3246120" y="1325880"/>
-            <a:ext cx="1645920" cy="868680"/>
-          </a:xfrm>
-          <a:prstGeom prst="roundRect">
-            <a:avLst/>
-          </a:prstGeom>
-          <a:solidFill>
-            <a:srgbClr val="FFFFFF"/>
-          </a:solidFill>
-          <a:ln w="13970">
-            <a:solidFill>
-              <a:srgbClr val="3165A3"/>
-            </a:solidFill>
-          </a:ln>
-        </p:spPr>
-        <p:style>
-          <a:lnRef idx="1">
-            <a:schemeClr val="accent1"/>
-          </a:lnRef>
-          <a:fillRef idx="3">
-            <a:schemeClr val="accent1"/>
-          </a:fillRef>
-          <a:effectRef idx="2">
-            <a:schemeClr val="accent1"/>
-          </a:effectRef>
-          <a:fontRef idx="minor">
-            <a:schemeClr val="lt1"/>
-          </a:fontRef>
-        </p:style>
-        <p:txBody>
-          <a:bodyPr rtlCol="0" anchor="ctr" lIns="73152" rIns="73152" tIns="54864" bIns="54864"/>
-          <a:lstStyle/>
-          <a:p>
-            <a:pPr algn="ctr"/>
-            <a:r>
-              <a:rPr sz="1300" b="1">
-                <a:solidFill>
-                  <a:srgbClr val="20252A"/>
-                </a:solidFill>
-                <a:latin typeface="Aptos"/>
-              </a:rPr>
-              <a:t>source checkpoint</a:t>
-            </a:r>
-          </a:p>
-        </p:txBody>
-      </p:sp>
-      <p:sp>
-        <p:nvSpPr>
-          <p:cNvPr id="5" name="Rounded Rectangle 4"/>
-          <p:cNvSpPr/>
-          <p:nvPr/>
-        </p:nvSpPr>
-        <p:spPr>
-          <a:xfrm>
-            <a:off x="777240" y="3063240"/>
-            <a:ext cx="2011680" cy="868680"/>
-          </a:xfrm>
-          <a:prstGeom prst="roundRect">
-            <a:avLst/>
-          </a:prstGeom>
-          <a:solidFill>
-            <a:srgbClr val="E0F1E5"/>
-          </a:solidFill>
-          <a:ln w="13970">
-            <a:solidFill>
-              <a:srgbClr val="539A5D"/>
-            </a:solidFill>
-          </a:ln>
-        </p:spPr>
-        <p:style>
-          <a:lnRef idx="1">
-            <a:schemeClr val="accent1"/>
-          </a:lnRef>
-          <a:fillRef idx="3">
-            <a:schemeClr val="accent1"/>
-          </a:fillRef>
-          <a:effectRef idx="2">
-            <a:schemeClr val="accent1"/>
-          </a:effectRef>
-          <a:fontRef idx="minor">
-            <a:schemeClr val="lt1"/>
-          </a:fontRef>
-        </p:style>
-        <p:txBody>
-          <a:bodyPr rtlCol="0" anchor="ctr" lIns="73152" rIns="73152" tIns="54864" bIns="54864"/>
-          <a:lstStyle/>
-          <a:p>
-            <a:pPr algn="ctr"/>
-            <a:r>
-              <a:rPr sz="1300" b="1">
-                <a:solidFill>
-                  <a:srgbClr val="20252A"/>
-                </a:solidFill>
-                <a:latin typeface="Aptos"/>
-              </a:rPr>
-              <a:t>zebrafish UCE
-cell states</a:t>
-            </a:r>
-          </a:p>
-        </p:txBody>
-      </p:sp>
-      <p:sp>
-        <p:nvSpPr>
-          <p:cNvPr id="6" name="Rounded Rectangle 5"/>
-          <p:cNvSpPr/>
-          <p:nvPr/>
-        </p:nvSpPr>
-        <p:spPr>
-          <a:xfrm>
-            <a:off x="3246120" y="3063240"/>
-            <a:ext cx="1645920" cy="868680"/>
-          </a:xfrm>
-          <a:prstGeom prst="roundRect">
-            <a:avLst/>
-          </a:prstGeom>
-          <a:solidFill>
-            <a:srgbClr val="F9EECF"/>
-          </a:solidFill>
-          <a:ln w="13970">
-            <a:solidFill>
-              <a:srgbClr val="D69E2E"/>
-            </a:solidFill>
-          </a:ln>
-        </p:spPr>
-        <p:style>
-          <a:lnRef idx="1">
-            <a:schemeClr val="accent1"/>
-          </a:lnRef>
-          <a:fillRef idx="3">
-            <a:schemeClr val="accent1"/>
-          </a:fillRef>
-          <a:effectRef idx="2">
-            <a:schemeClr val="accent1"/>
-          </a:effectRef>
-          <a:fontRef idx="minor">
-            <a:schemeClr val="lt1"/>
-          </a:fontRef>
-        </p:style>
-        <p:txBody>
-          <a:bodyPr rtlCol="0" anchor="ctr" lIns="73152" rIns="73152" tIns="54864" bIns="54864"/>
-          <a:lstStyle/>
-          <a:p>
-            <a:pPr algn="ctr"/>
-            <a:r>
-              <a:rPr sz="1300" b="1">
-                <a:solidFill>
-                  <a:srgbClr val="20252A"/>
-                </a:solidFill>
-                <a:latin typeface="Aptos"/>
-              </a:rPr>
-              <a:t>zebrafish cCRE
-sequence tokens</a:t>
-            </a:r>
-          </a:p>
-        </p:txBody>
-      </p:sp>
-      <p:sp>
-        <p:nvSpPr>
-          <p:cNvPr id="7" name="Rounded Rectangle 6"/>
-          <p:cNvSpPr/>
-          <p:nvPr/>
-        </p:nvSpPr>
-        <p:spPr>
-          <a:xfrm>
-            <a:off x="5486400" y="960120"/>
-            <a:ext cx="1554480" cy="640080"/>
-          </a:xfrm>
-          <a:prstGeom prst="roundRect">
-            <a:avLst/>
-          </a:prstGeom>
-          <a:solidFill>
-            <a:srgbClr val="F9EECF"/>
-          </a:solidFill>
-          <a:ln w="13970">
-            <a:solidFill>
-              <a:srgbClr val="D69E2E"/>
-            </a:solidFill>
-          </a:ln>
-        </p:spPr>
-        <p:style>
-          <a:lnRef idx="1">
-            <a:schemeClr val="accent1"/>
-          </a:lnRef>
-          <a:fillRef idx="3">
-            <a:schemeClr val="accent1"/>
-          </a:fillRef>
-          <a:effectRef idx="2">
-            <a:schemeClr val="accent1"/>
-          </a:effectRef>
-          <a:fontRef idx="minor">
-            <a:schemeClr val="lt1"/>
-          </a:fontRef>
-        </p:style>
-        <p:txBody>
-          <a:bodyPr rtlCol="0" anchor="ctr" lIns="73152" rIns="73152" tIns="54864" bIns="54864"/>
-          <a:lstStyle/>
-          <a:p>
-            <a:pPr algn="ctr"/>
-            <a:r>
-              <a:rPr sz="1300" b="1">
-                <a:solidFill>
-                  <a:srgbClr val="20252A"/>
-                </a:solidFill>
-                <a:latin typeface="Aptos"/>
-              </a:rPr>
-              <a:t>zero-shot</a:t>
-            </a:r>
-          </a:p>
-        </p:txBody>
-      </p:sp>
-      <p:sp>
-        <p:nvSpPr>
-          <p:cNvPr id="8" name="Rounded Rectangle 7"/>
-          <p:cNvSpPr/>
-          <p:nvPr/>
-        </p:nvSpPr>
-        <p:spPr>
-          <a:xfrm>
-            <a:off x="5486400" y="1965960"/>
-            <a:ext cx="1554480" cy="640080"/>
-          </a:xfrm>
-          <a:prstGeom prst="roundRect">
-            <a:avLst/>
-          </a:prstGeom>
-          <a:solidFill>
-            <a:srgbClr val="E0F1E5"/>
-          </a:solidFill>
-          <a:ln w="13970">
-            <a:solidFill>
-              <a:srgbClr val="539A5D"/>
-            </a:solidFill>
-          </a:ln>
-        </p:spPr>
-        <p:style>
-          <a:lnRef idx="1">
-            <a:schemeClr val="accent1"/>
-          </a:lnRef>
-          <a:fillRef idx="3">
-            <a:schemeClr val="accent1"/>
-          </a:fillRef>
-          <a:effectRef idx="2">
-            <a:schemeClr val="accent1"/>
-          </a:effectRef>
-          <a:fontRef idx="minor">
-            <a:schemeClr val="lt1"/>
-          </a:fontRef>
-        </p:style>
-        <p:txBody>
-          <a:bodyPr rtlCol="0" anchor="ctr" lIns="73152" rIns="73152" tIns="54864" bIns="54864"/>
-          <a:lstStyle/>
-          <a:p>
-            <a:pPr algn="ctr"/>
-            <a:r>
-              <a:rPr sz="1300" b="1">
-                <a:solidFill>
-                  <a:srgbClr val="20252A"/>
-                </a:solidFill>
-                <a:latin typeface="Aptos"/>
-              </a:rPr>
-              <a:t>fine-tuned</a:t>
-            </a:r>
-          </a:p>
-        </p:txBody>
-      </p:sp>
-      <p:sp>
-        <p:nvSpPr>
-          <p:cNvPr id="9" name="Rounded Rectangle 8"/>
-          <p:cNvSpPr/>
-          <p:nvPr/>
-        </p:nvSpPr>
-        <p:spPr>
-          <a:xfrm>
-            <a:off x="5486400" y="2971800"/>
-            <a:ext cx="1554480" cy="640080"/>
-          </a:xfrm>
-          <a:prstGeom prst="roundRect">
-            <a:avLst/>
-          </a:prstGeom>
-          <a:solidFill>
-            <a:srgbClr val="E1EBF7"/>
-          </a:solidFill>
-          <a:ln w="13970">
-            <a:solidFill>
-              <a:srgbClr val="3165A3"/>
-            </a:solidFill>
-          </a:ln>
-        </p:spPr>
-        <p:style>
-          <a:lnRef idx="1">
-            <a:schemeClr val="accent1"/>
-          </a:lnRef>
-          <a:fillRef idx="3">
-            <a:schemeClr val="accent1"/>
-          </a:fillRef>
-          <a:effectRef idx="2">
-            <a:schemeClr val="accent1"/>
-          </a:effectRef>
-          <a:fontRef idx="minor">
-            <a:schemeClr val="lt1"/>
-          </a:fontRef>
-        </p:style>
-        <p:txBody>
-          <a:bodyPr rtlCol="0" anchor="ctr" lIns="73152" rIns="73152" tIns="54864" bIns="54864"/>
-          <a:lstStyle/>
-          <a:p>
-            <a:pPr algn="ctr"/>
-            <a:r>
-              <a:rPr sz="1300" b="1">
-                <a:solidFill>
-                  <a:srgbClr val="20252A"/>
-                </a:solidFill>
-                <a:latin typeface="Aptos"/>
-              </a:rPr>
-              <a:t>zebrafish only</a:t>
-            </a:r>
-          </a:p>
-        </p:txBody>
-      </p:sp>
-      <p:sp>
-        <p:nvSpPr>
-          <p:cNvPr id="10" name="Rounded Rectangle 9"/>
-          <p:cNvSpPr/>
-          <p:nvPr/>
-        </p:nvSpPr>
-        <p:spPr>
-          <a:xfrm>
-            <a:off x="7635240" y="2240280"/>
-            <a:ext cx="3017520" cy="960120"/>
-          </a:xfrm>
-          <a:prstGeom prst="roundRect">
-            <a:avLst/>
-          </a:prstGeom>
-          <a:solidFill>
-            <a:srgbClr val="FFFFFF"/>
-          </a:solidFill>
-          <a:ln w="13970">
-            <a:solidFill>
-              <a:srgbClr val="BE4B49"/>
-            </a:solidFill>
-          </a:ln>
-        </p:spPr>
-        <p:style>
-          <a:lnRef idx="1">
-            <a:schemeClr val="accent1"/>
-          </a:lnRef>
-          <a:fillRef idx="3">
-            <a:schemeClr val="accent1"/>
-          </a:fillRef>
-          <a:effectRef idx="2">
-            <a:schemeClr val="accent1"/>
-          </a:effectRef>
-          <a:fontRef idx="minor">
-            <a:schemeClr val="lt1"/>
-          </a:fontRef>
-        </p:style>
-        <p:txBody>
-          <a:bodyPr rtlCol="0" anchor="ctr" lIns="73152" rIns="73152" tIns="54864" bIns="54864"/>
-          <a:lstStyle/>
-          <a:p>
-            <a:pPr algn="ctr"/>
-            <a:r>
-              <a:rPr sz="1300" b="1">
-                <a:solidFill>
-                  <a:srgbClr val="20252A"/>
-                </a:solidFill>
-                <a:latin typeface="Aptos"/>
-              </a:rPr>
-              <a:t>held-out 36 and 72 hpf
-expression displacement</a:t>
-            </a:r>
-          </a:p>
-        </p:txBody>
-      </p:sp>
-      <p:cxnSp>
-        <p:nvCxnSpPr>
-          <p:cNvPr id="11" name="Connector 10"/>
-          <p:cNvCxnSpPr/>
-          <p:nvPr/>
-        </p:nvCxnSpPr>
-        <p:spPr>
-          <a:xfrm>
-            <a:off x="2788920" y="1755648"/>
-            <a:ext cx="457200" cy="0"/>
-          </a:xfrm>
-          <a:prstGeom prst="line">
-            <a:avLst/>
-          </a:prstGeom>
-          <a:ln w="25400">
-            <a:solidFill>
-              <a:srgbClr val="5C6773"/>
-            </a:solidFill>
-          </a:ln>
-        </p:spPr>
-        <p:style>
-          <a:lnRef idx="2">
-            <a:schemeClr val="accent1"/>
-          </a:lnRef>
-          <a:fillRef idx="0">
-            <a:schemeClr val="accent1"/>
-          </a:fillRef>
-          <a:effectRef idx="1">
-            <a:schemeClr val="accent1"/>
-          </a:effectRef>
-          <a:fontRef idx="minor">
-            <a:schemeClr val="tx1"/>
-          </a:fontRef>
-        </p:style>
-      </p:cxnSp>
-      <p:cxnSp>
-        <p:nvCxnSpPr>
-          <p:cNvPr id="12" name="Connector 11"/>
-          <p:cNvCxnSpPr/>
-          <p:nvPr/>
-        </p:nvCxnSpPr>
-        <p:spPr>
-          <a:xfrm flipV="1">
-            <a:off x="4892040" y="1280160"/>
-            <a:ext cx="594360" cy="475488"/>
-          </a:xfrm>
-          <a:prstGeom prst="line">
-            <a:avLst/>
-          </a:prstGeom>
-          <a:ln w="25400">
-            <a:solidFill>
-              <a:srgbClr val="5C6773"/>
-            </a:solidFill>
-          </a:ln>
-        </p:spPr>
-        <p:style>
-          <a:lnRef idx="2">
-            <a:schemeClr val="accent1"/>
-          </a:lnRef>
-          <a:fillRef idx="0">
-            <a:schemeClr val="accent1"/>
-          </a:fillRef>
-          <a:effectRef idx="1">
-            <a:schemeClr val="accent1"/>
-          </a:effectRef>
-          <a:fontRef idx="minor">
-            <a:schemeClr val="tx1"/>
-          </a:fontRef>
-        </p:style>
-      </p:cxnSp>
-      <p:cxnSp>
-        <p:nvCxnSpPr>
-          <p:cNvPr id="13" name="Connector 12"/>
-          <p:cNvCxnSpPr/>
-          <p:nvPr/>
-        </p:nvCxnSpPr>
-        <p:spPr>
-          <a:xfrm flipV="1">
-            <a:off x="4892040" y="2286000"/>
-            <a:ext cx="594360" cy="1207008"/>
-          </a:xfrm>
-          <a:prstGeom prst="line">
-            <a:avLst/>
-          </a:prstGeom>
-          <a:ln w="25400">
-            <a:solidFill>
-              <a:srgbClr val="5C6773"/>
-            </a:solidFill>
-          </a:ln>
-        </p:spPr>
-        <p:style>
-          <a:lnRef idx="2">
-            <a:schemeClr val="accent1"/>
-          </a:lnRef>
-          <a:fillRef idx="0">
-            <a:schemeClr val="accent1"/>
-          </a:fillRef>
-          <a:effectRef idx="1">
-            <a:schemeClr val="accent1"/>
-          </a:effectRef>
-          <a:fontRef idx="minor">
-            <a:schemeClr val="tx1"/>
-          </a:fontRef>
-        </p:style>
-      </p:cxnSp>
-      <p:cxnSp>
-        <p:nvCxnSpPr>
-          <p:cNvPr id="14" name="Connector 13"/>
-          <p:cNvCxnSpPr/>
-          <p:nvPr/>
-        </p:nvCxnSpPr>
-        <p:spPr>
-          <a:xfrm flipV="1">
-            <a:off x="4892040" y="3291840"/>
-            <a:ext cx="594360" cy="201168"/>
-          </a:xfrm>
-          <a:prstGeom prst="line">
-            <a:avLst/>
-          </a:prstGeom>
-          <a:ln w="25400">
-            <a:solidFill>
-              <a:srgbClr val="5C6773"/>
-            </a:solidFill>
-          </a:ln>
-        </p:spPr>
-        <p:style>
-          <a:lnRef idx="2">
-            <a:schemeClr val="accent1"/>
-          </a:lnRef>
-          <a:fillRef idx="0">
-            <a:schemeClr val="accent1"/>
-          </a:fillRef>
-          <a:effectRef idx="1">
-            <a:schemeClr val="accent1"/>
-          </a:effectRef>
-          <a:fontRef idx="minor">
-            <a:schemeClr val="tx1"/>
-          </a:fontRef>
-        </p:style>
-      </p:cxnSp>
-      <p:cxnSp>
-        <p:nvCxnSpPr>
-          <p:cNvPr id="15" name="Connector 14"/>
-          <p:cNvCxnSpPr/>
-          <p:nvPr/>
-        </p:nvCxnSpPr>
-        <p:spPr>
-          <a:xfrm>
-            <a:off x="7040880" y="2331720"/>
-            <a:ext cx="594360" cy="365760"/>
-          </a:xfrm>
-          <a:prstGeom prst="line">
-            <a:avLst/>
-          </a:prstGeom>
-          <a:ln w="25400">
-            <a:solidFill>
-              <a:srgbClr val="5C6773"/>
-            </a:solidFill>
-          </a:ln>
-        </p:spPr>
-        <p:style>
-          <a:lnRef idx="2">
-            <a:schemeClr val="accent1"/>
-          </a:lnRef>
-          <a:fillRef idx="0">
-            <a:schemeClr val="accent1"/>
-          </a:fillRef>
-          <a:effectRef idx="1">
-            <a:schemeClr val="accent1"/>
-          </a:effectRef>
-          <a:fontRef idx="minor">
-            <a:schemeClr val="tx1"/>
-          </a:fontRef>
-        </p:style>
-      </p:cxnSp>
-      <p:sp>
-        <p:nvSpPr>
-          <p:cNvPr id="16" name="TextBox 15"/>
-          <p:cNvSpPr txBox="1"/>
-          <p:nvPr/>
-        </p:nvSpPr>
-        <p:spPr>
-          <a:xfrm>
-            <a:off x="1005840" y="5212080"/>
-            <a:ext cx="9966960" cy="411480"/>
-          </a:xfrm>
-          <a:prstGeom prst="rect">
-            <a:avLst/>
-          </a:prstGeom>
-          <a:noFill/>
-        </p:spPr>
-        <p:txBody>
-          <a:bodyPr wrap="none" lIns="36576" rIns="36576" tIns="18288" bIns="18288" anchor="t">
-            <a:spAutoFit/>
-          </a:bodyPr>
-          <a:lstStyle/>
-          <a:p>
-            <a:pPr algn="ctr"/>
-            <a:r>
-              <a:rPr sz="1500" b="1">
-                <a:solidFill>
-                  <a:srgbClr val="20252A"/>
-                </a:solidFill>
-                <a:latin typeface="Aptos"/>
-              </a:rPr>
-              <a:t>Two time conventions are evaluated: physical days and organism-relative [0,1] time.</a:t>
-            </a:r>
-          </a:p>
-        </p:txBody>
-      </p:sp>
-    </p:spTree>
-  </p:cSld>
-  <p:clrMapOvr>
-    <a:masterClrMapping/>
-  </p:clrMapOvr>
-</p:sld>
-</file>
-
 <file path=ppt/theme/theme1.xml><?xml version="1.0" encoding="utf-8"?>
 <a:theme xmlns:a="http://schemas.openxmlformats.org/drawingml/2006/main" name="Office Theme">
   <a:themeElements>

</xml_diff>

<commit_message>
Clarify conditional and causal UCE evaluation
</commit_message>
<xml_diff>
--- a/docs/stream_project_slide_deck.pptx
+++ b/docs/stream_project_slide_deck.pptx
@@ -4763,7 +4763,7 @@
                 </a:solidFill>
                 <a:latin typeface="Aptos"/>
               </a:rPr>
-              <a:t>Zebrafish transfer is challenging: fine-tuning is best learned model in relative time</a:t>
+              <a:t>Zebrafish transfer results are conditional-fit diagnostics pending causal rollout</a:t>
             </a:r>
           </a:p>
         </p:txBody>
@@ -5255,7 +5255,7 @@
                 </a:solidFill>
                 <a:latin typeface="Aptos"/>
               </a:rPr>
-              <a:t>Cross-species generalization depends on the time coordinate and training regime</a:t>
+              <a:t>Legacy cross-species conditional fit depends on time coordinate and training regime</a:t>
             </a:r>
           </a:p>
         </p:txBody>
@@ -6164,7 +6164,7 @@
                 </a:solidFill>
                 <a:latin typeface="Aptos"/>
               </a:rPr>
-              <a:t>Current picture: 10k + UCE + cross-attention works in mouse; transfer needs stronger alignment</a:t>
+              <a:t>Current picture: 10k improves conditional fit; causal UCE rollout is the required test</a:t>
             </a:r>
           </a:p>
         </p:txBody>
@@ -6371,7 +6371,7 @@
                           </a:solidFill>
                           <a:latin typeface="Aptos"/>
                         </a:rPr>
-                        <a:t>UCE helps STREAM</a:t>
+                        <a:t>Legacy UCE fit improves</a:t>
                       </a:r>
                     </a:p>
                   </a:txBody>
@@ -6394,7 +6394,7 @@
                           </a:solidFill>
                           <a:latin typeface="Aptos"/>
                         </a:rPr>
-                        <a:t>Best mouse model is 10k UCE cross-attn</a:t>
+                        <a:t>Forecasting claim requires online UCE rollout</a:t>
                       </a:r>
                     </a:p>
                   </a:txBody>
@@ -6797,7 +6797,7 @@
                 </a:solidFill>
                 <a:latin typeface="Aptos"/>
               </a:rPr>
-              <a:t>Main result: modeling more genes is helpful at 10k, especially when UCE state and cross-attention are combined.</a:t>
+              <a:t>Main result: 10k genes improve conditional fit; endpoint transport is now evaluated without destination leakage.</a:t>
             </a:r>
           </a:p>
         </p:txBody>
@@ -7850,7 +7850,7 @@
                 </a:solidFill>
                 <a:latin typeface="Aptos"/>
               </a:rPr>
-              <a:t>Held-out timepoints test temporal interpolation around missing stages</a:t>
+              <a:t>Causal rollout predicts held-out stages from observed source cells</a:t>
             </a:r>
           </a:p>
         </p:txBody>
@@ -8019,7 +8019,7 @@
                 </a:solidFill>
                 <a:latin typeface="Aptos"/>
               </a:rPr>
-              <a:t>Multi-timepoint CFM trains on adjacent intervals and scores intervals touching held-out stages</a:t>
+              <a:t>Multi-timepoint CFM fits paths; causal evaluation rolls only into held-out stages</a:t>
             </a:r>
           </a:p>
         </p:txBody>
@@ -8887,8 +8887,8 @@
         </p:nvSpPr>
         <p:spPr>
           <a:xfrm>
-            <a:off x="2103120" y="2788920"/>
-            <a:ext cx="7863840" cy="228600"/>
+            <a:off x="1508760" y="2788920"/>
+            <a:ext cx="9052560" cy="228600"/>
           </a:xfrm>
           <a:prstGeom prst="rect">
             <a:avLst/>
@@ -8909,7 +8909,7 @@
                 </a:solidFill>
                 <a:latin typeface="Aptos"/>
               </a:rPr>
-              <a:t>green = trained adjacent intervals     red = held-out-touching evaluation intervals</a:t>
+              <a:t>green = training intervals     red = excluded intervals; causal scoring uses observed-to-held-out direction</a:t>
             </a:r>
           </a:p>
         </p:txBody>
@@ -10017,7 +10017,7 @@
                 </a:solidFill>
                 <a:latin typeface="Aptos"/>
               </a:rPr>
-              <a:t>UCE changes the state representation; CFM targets remain expression-valued</a:t>
+              <a:t>Online UCE closes the expression-space vector field without endpoint leakage</a:t>
             </a:r>
           </a:p>
         </p:txBody>
@@ -10202,11 +10202,11 @@
             <a:avLst/>
           </a:prstGeom>
           <a:solidFill>
-            <a:srgbClr val="E0F1E5"/>
+            <a:srgbClr val="E1EBF7"/>
           </a:solidFill>
           <a:ln w="13970">
             <a:solidFill>
-              <a:srgbClr val="539A5D"/>
+              <a:srgbClr val="3165A3"/>
             </a:solidFill>
           </a:ln>
         </p:spPr>
@@ -10236,8 +10236,8 @@
                 </a:solidFill>
                 <a:latin typeface="Aptos"/>
               </a:rPr>
-              <a:t>frozen UCE
-encoder</a:t>
+              <a:t>interpolated
+expression x_t</a:t>
             </a:r>
           </a:p>
         </p:txBody>
@@ -10291,8 +10291,8 @@
                 </a:solidFill>
                 <a:latin typeface="Aptos"/>
               </a:rPr>
-              <a:t>interpolated
-u_t in R^1280</a:t>
+              <a:t>frozen UCE
+E(x_t) in R^1280</a:t>
             </a:r>
           </a:p>
         </p:txBody>
@@ -10796,7 +10796,7 @@
                           </a:solidFill>
                           <a:latin typeface="Aptos"/>
                         </a:rPr>
-                        <a:t>UCE state</a:t>
+                        <a:t>Online UCE</a:t>
                       </a:r>
                     </a:p>
                   </a:txBody>
@@ -10819,7 +10819,7 @@
                           </a:solidFill>
                           <a:latin typeface="Aptos"/>
                         </a:rPr>
-                        <a:t>u_t in R^1280</a:t>
+                        <a:t>E(x_t) in R^1280</a:t>
                       </a:r>
                     </a:p>
                   </a:txBody>
@@ -11243,7 +11243,7 @@
                 </a:solidFill>
                 <a:latin typeface="Aptos"/>
               </a:rPr>
-              <a:t>Mouse: 10k genes lowers full-panel loss; cross-attention is best by MSE</a:t>
+              <a:t>Mouse conditional-fit diagnostic: 10k genes lowers full-panel velocity loss</a:t>
             </a:r>
           </a:p>
         </p:txBody>
@@ -11620,7 +11620,7 @@
                 </a:solidFill>
                 <a:latin typeface="Aptos"/>
               </a:rPr>
-              <a:t>Full-panel losses compare each model on its own selected genes; the legacy-panel slide controls for output genes.</a:t>
+              <a:t>These OT-path losses use both endpoints and diagnose vector-field fit; they are not causal forecasts.</a:t>
             </a:r>
           </a:p>
         </p:txBody>
@@ -11681,7 +11681,7 @@
                 </a:solidFill>
                 <a:latin typeface="Aptos"/>
               </a:rPr>
-              <a:t>Fair legacy-panel scoring shows the 10k cross-attention gain is real</a:t>
+              <a:t>Conditional fit on a fixed legacy panel improves for 10k cross-attention</a:t>
             </a:r>
           </a:p>
         </p:txBody>
@@ -11902,7 +11902,7 @@
                 </a:solidFill>
                 <a:latin typeface="Aptos"/>
               </a:rPr>
-              <a:t>Numbers are held-out MSE on the same original gene panel; lower is better.</a:t>
+              <a:t>Numbers are OT-path velocity MSE on the same original gene panel; lower is better.</a:t>
             </a:r>
           </a:p>
         </p:txBody>
@@ -11963,7 +11963,7 @@
                 </a:solidFill>
                 <a:latin typeface="Aptos"/>
               </a:rPr>
-              <a:t>The best mouse model is 10k UCE cross-attention</a:t>
+              <a:t>Legacy UCE improves conditional fit but does not establish forecasting</a:t>
             </a:r>
           </a:p>
         </p:txBody>
@@ -12365,11 +12365,11 @@
             <a:avLst/>
           </a:prstGeom>
           <a:solidFill>
-            <a:srgbClr val="E0F1E5"/>
+            <a:srgbClr val="F9E0DC"/>
           </a:solidFill>
           <a:ln w="13970">
             <a:solidFill>
-              <a:srgbClr val="539A5D"/>
+              <a:srgbClr val="BE4B49"/>
             </a:solidFill>
           </a:ln>
         </p:spPr>
@@ -12399,7 +12399,7 @@
                 </a:solidFill>
                 <a:latin typeface="Aptos"/>
               </a:rPr>
-              <a:t>UCE helps when the model can use sequence-specific cell context</a:t>
+              <a:t>Legacy UCE interpolated both endpoint embeddings</a:t>
             </a:r>
           </a:p>
         </p:txBody>

</xml_diff>